<commit_message>
Added MAC ID lookup
</commit_message>
<xml_diff>
--- a/1 ACT AW - Intro.pptx
+++ b/1 ACT AW - Intro.pptx
@@ -5,7 +5,7 @@
     <p:sldMasterId id="2147483702" r:id="rId5"/>
   </p:sldMasterIdLst>
   <p:notesMasterIdLst>
-    <p:notesMasterId r:id="rId14"/>
+    <p:notesMasterId r:id="rId15"/>
   </p:notesMasterIdLst>
   <p:sldIdLst>
     <p:sldId id="506" r:id="rId6"/>
@@ -14,13 +14,14 @@
     <p:sldId id="312" r:id="rId9"/>
     <p:sldId id="310" r:id="rId10"/>
     <p:sldId id="311" r:id="rId11"/>
-    <p:sldId id="507" r:id="rId12"/>
-    <p:sldId id="779" r:id="rId13"/>
+    <p:sldId id="781" r:id="rId12"/>
+    <p:sldId id="507" r:id="rId13"/>
+    <p:sldId id="779" r:id="rId14"/>
   </p:sldIdLst>
   <p:sldSz cx="12192000" cy="6858000"/>
   <p:notesSz cx="6858000" cy="9144000"/>
   <p:custDataLst>
-    <p:tags r:id="rId15"/>
+    <p:tags r:id="rId16"/>
   </p:custDataLst>
   <p:defaultTextStyle>
     <a:defPPr>
@@ -142,6 +143,11 @@
             <p14:sldId id="311"/>
           </p14:sldIdLst>
         </p14:section>
+        <p14:section name="MAC ID" id="{FEDD5FBB-3FE3-4B83-A476-335840C7ACD6}">
+          <p14:sldIdLst>
+            <p14:sldId id="781"/>
+          </p14:sldIdLst>
+        </p14:section>
         <p14:section name="Syllabus" id="{A31229EC-853B-4205-8E31-6B44F371A12E}">
           <p14:sldIdLst>
             <p14:sldId id="507"/>
@@ -5062,7 +5068,7 @@
           <a:p>
             <a:fld id="{2FC2648E-2733-4EC8-BEDA-1577DE2D3D01}" type="datetimeFigureOut">
               <a:rPr lang="en-US" smtClean="0"/>
-              <a:t>10/15/2026</a:t>
+              <a:t>10/19/2026</a:t>
             </a:fld>
             <a:endParaRPr lang="en-US"/>
           </a:p>
@@ -5369,7 +5375,7 @@
           <a:p>
             <a:fld id="{8CF61943-3342-4554-8403-118C8C1529D5}" type="datetimeFigureOut">
               <a:rPr lang="en-US" smtClean="0"/>
-              <a:t>10/15/2026</a:t>
+              <a:t>10/19/2026</a:t>
             </a:fld>
             <a:endParaRPr lang="en-US"/>
           </a:p>
@@ -5907,7 +5913,7 @@
           <a:p>
             <a:fld id="{8CF61943-3342-4554-8403-118C8C1529D5}" type="datetimeFigureOut">
               <a:rPr lang="en-US" smtClean="0"/>
-              <a:t>10/15/2026</a:t>
+              <a:t>10/19/2026</a:t>
             </a:fld>
             <a:endParaRPr lang="en-US"/>
           </a:p>
@@ -9400,6 +9406,213 @@
           <p:cNvPr id="2" name="Text Placeholder 1">
             <a:extLst>
               <a:ext uri="{FF2B5EF4-FFF2-40B4-BE49-F238E27FC236}">
+                <a16:creationId xmlns:a16="http://schemas.microsoft.com/office/drawing/2014/main" id="{865F03D4-C60F-BCC2-00B2-3FC5A2869F43}"/>
+              </a:ext>
+            </a:extLst>
+          </p:cNvPr>
+          <p:cNvSpPr>
+            <a:spLocks noGrp="1"/>
+          </p:cNvSpPr>
+          <p:nvPr>
+            <p:ph type="body" sz="quarter" idx="10"/>
+          </p:nvPr>
+        </p:nvSpPr>
+        <p:spPr/>
+        <p:txBody>
+          <a:bodyPr/>
+          <a:lstStyle/>
+          <a:p>
+            <a:r>
+              <a:rPr lang="en-US" dirty="0"/>
+              <a:t>MAC ID Lookup</a:t>
+            </a:r>
+          </a:p>
+        </p:txBody>
+      </p:sp>
+      <p:sp>
+        <p:nvSpPr>
+          <p:cNvPr id="4" name="Text Placeholder 3">
+            <a:extLst>
+              <a:ext uri="{FF2B5EF4-FFF2-40B4-BE49-F238E27FC236}">
+                <a16:creationId xmlns:a16="http://schemas.microsoft.com/office/drawing/2014/main" id="{6CBFDCB8-2683-8890-D373-3B0A01A29E9D}"/>
+              </a:ext>
+            </a:extLst>
+          </p:cNvPr>
+          <p:cNvSpPr>
+            <a:spLocks noGrp="1"/>
+          </p:cNvSpPr>
+          <p:nvPr>
+            <p:ph type="body" sz="quarter" idx="12"/>
+          </p:nvPr>
+        </p:nvSpPr>
+        <p:spPr>
+          <a:xfrm>
+            <a:off x="270415" y="771556"/>
+            <a:ext cx="11658059" cy="5273644"/>
+          </a:xfrm>
+        </p:spPr>
+        <p:txBody>
+          <a:bodyPr/>
+          <a:lstStyle/>
+          <a:p>
+            <a:pPr marL="285750" indent="-285750">
+              <a:buFont typeface="Arial" panose="020B0604020202020204" pitchFamily="34" charset="0"/>
+              <a:buChar char="•"/>
+            </a:pPr>
+            <a:r>
+              <a:rPr lang="en-US" dirty="0">
+                <a:hlinkClick r:id="rId2"/>
+              </a:rPr>
+              <a:t>https://en.wikipedia.org/wiki/MAC_address</a:t>
+            </a:r>
+            <a:endParaRPr lang="en-US" dirty="0"/>
+          </a:p>
+          <a:p>
+            <a:pPr marL="285750" indent="-285750">
+              <a:buFont typeface="Arial" panose="020B0604020202020204" pitchFamily="34" charset="0"/>
+              <a:buChar char="•"/>
+            </a:pPr>
+            <a:r>
+              <a:rPr lang="en-US" dirty="0"/>
+              <a:t>Looking up the Medium Access Control (MAC) address</a:t>
+            </a:r>
+          </a:p>
+          <a:p>
+            <a:pPr marL="285750" indent="-285750">
+              <a:buFont typeface="Arial" panose="020B0604020202020204" pitchFamily="34" charset="0"/>
+              <a:buChar char="•"/>
+            </a:pPr>
+            <a:r>
+              <a:rPr lang="en-US" dirty="0"/>
+              <a:t>Important identification of device on local networks, wired or wireless</a:t>
+            </a:r>
+          </a:p>
+          <a:p>
+            <a:pPr marL="285750" indent="-285750">
+              <a:buFont typeface="Arial" panose="020B0604020202020204" pitchFamily="34" charset="0"/>
+              <a:buChar char="•"/>
+            </a:pPr>
+            <a:r>
+              <a:rPr lang="en-US" dirty="0"/>
+              <a:t>Works with Ethernet, </a:t>
+            </a:r>
+            <a:r>
+              <a:rPr lang="en-US" dirty="0" err="1"/>
+              <a:t>WiFi</a:t>
+            </a:r>
+            <a:r>
+              <a:rPr lang="en-US" dirty="0"/>
+              <a:t> and Bluetooth devices</a:t>
+            </a:r>
+          </a:p>
+          <a:p>
+            <a:pPr marL="285750" indent="-285750">
+              <a:buFont typeface="Arial" panose="020B0604020202020204" pitchFamily="34" charset="0"/>
+              <a:buChar char="•"/>
+            </a:pPr>
+            <a:r>
+              <a:rPr lang="en-US" dirty="0"/>
+              <a:t>Gives </a:t>
+            </a:r>
+            <a:r>
+              <a:rPr lang="en-US" dirty="0" err="1"/>
+              <a:t>Manfacturer</a:t>
+            </a:r>
+            <a:r>
+              <a:rPr lang="en-US" dirty="0"/>
+              <a:t> Organizationally Unique Identifier (OUI)</a:t>
+            </a:r>
+          </a:p>
+          <a:p>
+            <a:pPr marL="285750" indent="-285750">
+              <a:buFont typeface="Arial" panose="020B0604020202020204" pitchFamily="34" charset="0"/>
+              <a:buChar char="•"/>
+            </a:pPr>
+            <a:r>
+              <a:rPr lang="en-US" dirty="0">
+                <a:hlinkClick r:id="rId3"/>
+              </a:rPr>
+              <a:t>https://maclookup.app/</a:t>
+            </a:r>
+            <a:r>
+              <a:rPr lang="en-US" dirty="0"/>
+              <a:t> </a:t>
+            </a:r>
+          </a:p>
+          <a:p>
+            <a:pPr marL="285750" indent="-285750">
+              <a:buFont typeface="Arial" panose="020B0604020202020204" pitchFamily="34" charset="0"/>
+              <a:buChar char="•"/>
+            </a:pPr>
+            <a:endParaRPr lang="en-US" dirty="0"/>
+          </a:p>
+        </p:txBody>
+      </p:sp>
+      <p:pic>
+        <p:nvPicPr>
+          <p:cNvPr id="6" name="Picture 5">
+            <a:extLst>
+              <a:ext uri="{FF2B5EF4-FFF2-40B4-BE49-F238E27FC236}">
+                <a16:creationId xmlns:a16="http://schemas.microsoft.com/office/drawing/2014/main" id="{17233AFC-FA66-F154-7C50-1D6B83AEC69F}"/>
+              </a:ext>
+            </a:extLst>
+          </p:cNvPr>
+          <p:cNvPicPr>
+            <a:picLocks noChangeAspect="1"/>
+          </p:cNvPicPr>
+          <p:nvPr/>
+        </p:nvPicPr>
+        <p:blipFill>
+          <a:blip r:embed="rId4"/>
+          <a:stretch>
+            <a:fillRect/>
+          </a:stretch>
+        </p:blipFill>
+        <p:spPr>
+          <a:xfrm>
+            <a:off x="3219199" y="3865691"/>
+            <a:ext cx="5753599" cy="2179509"/>
+          </a:xfrm>
+          <a:prstGeom prst="rect">
+            <a:avLst/>
+          </a:prstGeom>
+        </p:spPr>
+      </p:pic>
+    </p:spTree>
+    <p:extLst>
+      <p:ext uri="{BB962C8B-B14F-4D97-AF65-F5344CB8AC3E}">
+        <p14:creationId xmlns:p14="http://schemas.microsoft.com/office/powerpoint/2010/main" val="4027383213"/>
+      </p:ext>
+    </p:extLst>
+  </p:cSld>
+  <p:clrMapOvr>
+    <a:masterClrMapping/>
+  </p:clrMapOvr>
+</p:sld>
+</file>
+
+<file path=ppt/slides/slide8.xml><?xml version="1.0" encoding="utf-8"?>
+<p:sld xmlns:a="http://schemas.openxmlformats.org/drawingml/2006/main" xmlns:r="http://schemas.openxmlformats.org/officeDocument/2006/relationships" xmlns:p="http://schemas.openxmlformats.org/presentationml/2006/main">
+  <p:cSld>
+    <p:spTree>
+      <p:nvGrpSpPr>
+        <p:cNvPr id="1" name=""/>
+        <p:cNvGrpSpPr/>
+        <p:nvPr/>
+      </p:nvGrpSpPr>
+      <p:grpSpPr>
+        <a:xfrm>
+          <a:off x="0" y="0"/>
+          <a:ext cx="0" cy="0"/>
+          <a:chOff x="0" y="0"/>
+          <a:chExt cx="0" cy="0"/>
+        </a:xfrm>
+      </p:grpSpPr>
+      <p:sp>
+        <p:nvSpPr>
+          <p:cNvPr id="2" name="Text Placeholder 1">
+            <a:extLst>
+              <a:ext uri="{FF2B5EF4-FFF2-40B4-BE49-F238E27FC236}">
                 <a16:creationId xmlns:a16="http://schemas.microsoft.com/office/drawing/2014/main" id="{168CC41A-92DC-4526-9165-E4D3020A5F9A}"/>
               </a:ext>
             </a:extLst>
@@ -9447,7 +9660,7 @@
         </p:spPr>
         <p:txBody>
           <a:bodyPr>
-            <a:normAutofit lnSpcReduction="10000"/>
+            <a:normAutofit fontScale="92500" lnSpcReduction="10000"/>
           </a:bodyPr>
           <a:lstStyle/>
           <a:p>
@@ -9457,14 +9670,21 @@
             </a:pPr>
             <a:r>
               <a:rPr lang="en-US" sz="1600" b="1" dirty="0"/>
-              <a:t>FCC ID</a:t>
+              <a:t>Intro</a:t>
             </a:r>
           </a:p>
           <a:p>
             <a:pPr marL="971550" lvl="1" indent="-285750"/>
             <a:r>
               <a:rPr lang="en-US" sz="1400" dirty="0"/>
-              <a:t>Lookup</a:t>
+              <a:t>FCC ID Lookup</a:t>
+            </a:r>
+          </a:p>
+          <a:p>
+            <a:pPr marL="971550" lvl="1" indent="-285750"/>
+            <a:r>
+              <a:rPr lang="en-US" sz="1400" dirty="0"/>
+              <a:t>MAC ID Lookup</a:t>
             </a:r>
           </a:p>
           <a:p>
@@ -9658,7 +9878,7 @@
 </p:sld>
 </file>
 
-<file path=ppt/slides/slide8.xml><?xml version="1.0" encoding="utf-8"?>
+<file path=ppt/slides/slide9.xml><?xml version="1.0" encoding="utf-8"?>
 <p:sld xmlns:a="http://schemas.openxmlformats.org/drawingml/2006/main" xmlns:r="http://schemas.openxmlformats.org/officeDocument/2006/relationships" xmlns:p="http://schemas.openxmlformats.org/presentationml/2006/main">
   <p:cSld>
     <p:spTree>
@@ -10554,22 +10774,6 @@
 </file>
 
 <file path=customXml/item1.xml><?xml version="1.0" encoding="utf-8"?>
-<p:properties xmlns:p="http://schemas.microsoft.com/office/2006/metadata/properties" xmlns:xsi="http://www.w3.org/2001/XMLSchema-instance" xmlns:pc="http://schemas.microsoft.com/office/infopath/2007/PartnerControls">
-  <documentManagement>
-    <_dlc_DocId xmlns="c7a77415-c4a3-4262-8430-671f3e8707b6">7J4PPY27XH2W-901365475-257158</_dlc_DocId>
-    <_dlc_DocIdUrl xmlns="c7a77415-c4a3-4262-8430-671f3e8707b6">
-      <Url>https://automotivei.sharepoint.com/sites/PMO/_layouts/15/DocIdRedir.aspx?ID=7J4PPY27XH2W-901365475-257158</Url>
-      <Description>7J4PPY27XH2W-901365475-257158</Description>
-    </_dlc_DocIdUrl>
-    <TaxCatchAll xmlns="c7a77415-c4a3-4262-8430-671f3e8707b6" xsi:nil="true"/>
-    <lcf76f155ced4ddcb4097134ff3c332f xmlns="69a7259e-7a2c-42d5-bc84-25eccf0dce8b">
-      <Terms xmlns="http://schemas.microsoft.com/office/infopath/2007/PartnerControls"/>
-    </lcf76f155ced4ddcb4097134ff3c332f>
-  </documentManagement>
-</p:properties>
-</file>
-
-<file path=customXml/item2.xml><?xml version="1.0" encoding="utf-8"?>
 <?mso-contentType ?>
 <spe:Receivers xmlns:spe="http://schemas.microsoft.com/sharepoint/events">
   <Receiver>
@@ -10619,16 +10823,23 @@
 </spe:Receivers>
 </file>
 
-<file path=customXml/item3.xml><?xml version="1.0" encoding="utf-8"?>
-<?mso-contentType ?>
-<FormTemplates xmlns="http://schemas.microsoft.com/sharepoint/v3/contenttype/forms">
-  <Display>DocumentLibraryForm</Display>
-  <Edit>DocumentLibraryForm</Edit>
-  <New>DocumentLibraryForm</New>
-</FormTemplates>
+<file path=customXml/item2.xml><?xml version="1.0" encoding="utf-8"?>
+<p:properties xmlns:p="http://schemas.microsoft.com/office/2006/metadata/properties" xmlns:xsi="http://www.w3.org/2001/XMLSchema-instance" xmlns:pc="http://schemas.microsoft.com/office/infopath/2007/PartnerControls">
+  <documentManagement>
+    <_dlc_DocId xmlns="c7a77415-c4a3-4262-8430-671f3e8707b6">7J4PPY27XH2W-901365475-257158</_dlc_DocId>
+    <_dlc_DocIdUrl xmlns="c7a77415-c4a3-4262-8430-671f3e8707b6">
+      <Url>https://automotivei.sharepoint.com/sites/PMO/_layouts/15/DocIdRedir.aspx?ID=7J4PPY27XH2W-901365475-257158</Url>
+      <Description>7J4PPY27XH2W-901365475-257158</Description>
+    </_dlc_DocIdUrl>
+    <TaxCatchAll xmlns="c7a77415-c4a3-4262-8430-671f3e8707b6" xsi:nil="true"/>
+    <lcf76f155ced4ddcb4097134ff3c332f xmlns="69a7259e-7a2c-42d5-bc84-25eccf0dce8b">
+      <Terms xmlns="http://schemas.microsoft.com/office/infopath/2007/PartnerControls"/>
+    </lcf76f155ced4ddcb4097134ff3c332f>
+  </documentManagement>
+</p:properties>
 </file>
 
-<file path=customXml/item4.xml><?xml version="1.0" encoding="utf-8"?>
+<file path=customXml/item3.xml><?xml version="1.0" encoding="utf-8"?>
 <ct:contentTypeSchema xmlns:ct="http://schemas.microsoft.com/office/2006/metadata/contentType" xmlns:ma="http://schemas.microsoft.com/office/2006/metadata/properties/metaAttributes" ct:_="" ma:_="" ma:contentTypeName="Document" ma:contentTypeID="0x01010067B86F8708159745A0B6896184DE9576" ma:contentTypeVersion="19" ma:contentTypeDescription="Create a new document." ma:contentTypeScope="" ma:versionID="493bf26d373952ea1ae3b9e24cd19b33">
   <xsd:schema xmlns:xsd="http://www.w3.org/2001/XMLSchema" xmlns:xs="http://www.w3.org/2001/XMLSchema" xmlns:p="http://schemas.microsoft.com/office/2006/metadata/properties" xmlns:ns2="c7a77415-c4a3-4262-8430-671f3e8707b6" xmlns:ns3="69a7259e-7a2c-42d5-bc84-25eccf0dce8b" targetNamespace="http://schemas.microsoft.com/office/2006/metadata/properties" ma:root="true" ma:fieldsID="69c00e31f84d56e19bb090b7ea67ab52" ns2:_="" ns3:_="">
     <xsd:import namespace="c7a77415-c4a3-4262-8430-671f3e8707b6"/>
@@ -10914,7 +11125,24 @@
 </ct:contentTypeSchema>
 </file>
 
+<file path=customXml/item4.xml><?xml version="1.0" encoding="utf-8"?>
+<?mso-contentType ?>
+<FormTemplates xmlns="http://schemas.microsoft.com/sharepoint/v3/contenttype/forms">
+  <Display>DocumentLibraryForm</Display>
+  <Edit>DocumentLibraryForm</Edit>
+  <New>DocumentLibraryForm</New>
+</FormTemplates>
+</file>
+
 <file path=customXml/itemProps1.xml><?xml version="1.0" encoding="utf-8"?>
+<ds:datastoreItem xmlns:ds="http://schemas.openxmlformats.org/officeDocument/2006/customXml" ds:itemID="{54C592EF-85C1-482B-896B-DED434B6FCCC}">
+  <ds:schemaRefs>
+    <ds:schemaRef ds:uri="http://schemas.microsoft.com/sharepoint/events"/>
+  </ds:schemaRefs>
+</ds:datastoreItem>
+</file>
+
+<file path=customXml/itemProps2.xml><?xml version="1.0" encoding="utf-8"?>
 <ds:datastoreItem xmlns:ds="http://schemas.openxmlformats.org/officeDocument/2006/customXml" ds:itemID="{E71A463F-9F4B-47AC-91AA-3962FD8F3CE5}">
   <ds:schemaRefs>
     <ds:schemaRef ds:uri="http://schemas.microsoft.com/office/2006/metadata/properties"/>
@@ -10925,23 +11153,7 @@
 </ds:datastoreItem>
 </file>
 
-<file path=customXml/itemProps2.xml><?xml version="1.0" encoding="utf-8"?>
-<ds:datastoreItem xmlns:ds="http://schemas.openxmlformats.org/officeDocument/2006/customXml" ds:itemID="{54C592EF-85C1-482B-896B-DED434B6FCCC}">
-  <ds:schemaRefs>
-    <ds:schemaRef ds:uri="http://schemas.microsoft.com/sharepoint/events"/>
-  </ds:schemaRefs>
-</ds:datastoreItem>
-</file>
-
 <file path=customXml/itemProps3.xml><?xml version="1.0" encoding="utf-8"?>
-<ds:datastoreItem xmlns:ds="http://schemas.openxmlformats.org/officeDocument/2006/customXml" ds:itemID="{84EE72F3-C956-4A5B-833F-E761B5D8ACD8}">
-  <ds:schemaRefs>
-    <ds:schemaRef ds:uri="http://schemas.microsoft.com/sharepoint/v3/contenttype/forms"/>
-  </ds:schemaRefs>
-</ds:datastoreItem>
-</file>
-
-<file path=customXml/itemProps4.xml><?xml version="1.0" encoding="utf-8"?>
 <ds:datastoreItem xmlns:ds="http://schemas.openxmlformats.org/officeDocument/2006/customXml" ds:itemID="{8FEF19B7-7529-453B-A7D5-A8465340F17A}">
   <ds:schemaRefs>
     <ds:schemaRef ds:uri="http://schemas.microsoft.com/office/2006/metadata/contentType"/>
@@ -10958,4 +11170,12 @@
     <ds:schemaRef ds:uri="http://schemas.microsoft.com/internal/obd"/>
   </ds:schemaRefs>
 </ds:datastoreItem>
+</file>
+
+<file path=customXml/itemProps4.xml><?xml version="1.0" encoding="utf-8"?>
+<ds:datastoreItem xmlns:ds="http://schemas.openxmlformats.org/officeDocument/2006/customXml" ds:itemID="{84EE72F3-C956-4A5B-833F-E761B5D8ACD8}">
+  <ds:schemaRefs>
+    <ds:schemaRef ds:uri="http://schemas.microsoft.com/sharepoint/v3/contenttype/forms"/>
+  </ds:schemaRefs>
+</ds:datastoreItem>
 </file>
</xml_diff>

<commit_message>
Post labs update.  Much work needed!
</commit_message>
<xml_diff>
--- a/1 ACT AW - Intro.pptx
+++ b/1 ACT AW - Intro.pptx
@@ -5,23 +5,15 @@
     <p:sldMasterId id="2147483702" r:id="rId5"/>
   </p:sldMasterIdLst>
   <p:notesMasterIdLst>
-    <p:notesMasterId r:id="rId15"/>
+    <p:notesMasterId r:id="rId7"/>
   </p:notesMasterIdLst>
   <p:sldIdLst>
     <p:sldId id="506" r:id="rId6"/>
-    <p:sldId id="507" r:id="rId7"/>
-    <p:sldId id="778" r:id="rId8"/>
-    <p:sldId id="780" r:id="rId9"/>
-    <p:sldId id="312" r:id="rId10"/>
-    <p:sldId id="310" r:id="rId11"/>
-    <p:sldId id="311" r:id="rId12"/>
-    <p:sldId id="781" r:id="rId13"/>
-    <p:sldId id="779" r:id="rId14"/>
   </p:sldIdLst>
   <p:sldSz cx="12192000" cy="6858000"/>
   <p:notesSz cx="6858000" cy="9144000"/>
   <p:custDataLst>
-    <p:tags r:id="rId16"/>
+    <p:tags r:id="rId8"/>
   </p:custDataLst>
   <p:defaultTextStyle>
     <a:defPPr>
@@ -119,47 +111,6 @@
     </a:lvl9pPr>
   </p:defaultTextStyle>
   <p:extLst>
-    <p:ext uri="{521415D9-36F7-43E2-AB2F-B90AF26B5E84}">
-      <p14:sectionLst xmlns:p14="http://schemas.microsoft.com/office/powerpoint/2010/main">
-        <p14:section name="Setup" id="{40EEF03E-46C1-4B91-8015-EA960149133A}">
-          <p14:sldIdLst>
-            <p14:sldId id="506"/>
-          </p14:sldIdLst>
-        </p14:section>
-        <p14:section name="Syllabus" id="{A31229EC-853B-4205-8E31-6B44F371A12E}">
-          <p14:sldIdLst>
-            <p14:sldId id="507"/>
-          </p14:sldIdLst>
-        </p14:section>
-        <p14:section name="US Laws" id="{40BC4D5D-0A57-4E8C-BB64-0F5BDF1B8E4A}">
-          <p14:sldIdLst>
-            <p14:sldId id="778"/>
-          </p14:sldIdLst>
-        </p14:section>
-        <p14:section name="Radio Modulation" id="{785EFAC1-38B5-4EBD-9C39-E3D4D03853B7}">
-          <p14:sldIdLst>
-            <p14:sldId id="780"/>
-          </p14:sldIdLst>
-        </p14:section>
-        <p14:section name="FCC ID" id="{996098ED-F625-41E8-8BD8-06E6CC46322C}">
-          <p14:sldIdLst>
-            <p14:sldId id="312"/>
-            <p14:sldId id="310"/>
-            <p14:sldId id="311"/>
-          </p14:sldIdLst>
-        </p14:section>
-        <p14:section name="MAC ID" id="{FEDD5FBB-3FE3-4B83-A476-335840C7ACD6}">
-          <p14:sldIdLst>
-            <p14:sldId id="781"/>
-          </p14:sldIdLst>
-        </p14:section>
-        <p14:section name="Appendix" id="{1A876553-7A3B-47A2-BDE9-1B0757EF4186}">
-          <p14:sldIdLst>
-            <p14:sldId id="779"/>
-          </p14:sldIdLst>
-        </p14:section>
-      </p14:sectionLst>
-    </p:ext>
     <p:ext uri="{EFAFB233-063F-42B5-8137-9DF3F51BA10A}">
       <p15:sldGuideLst xmlns:p15="http://schemas.microsoft.com/office/powerpoint/2012/main"/>
     </p:ext>
@@ -5068,7 +5019,7 @@
           <a:p>
             <a:fld id="{2FC2648E-2733-4EC8-BEDA-1577DE2D3D01}" type="datetimeFigureOut">
               <a:rPr lang="en-US" smtClean="0"/>
-              <a:t>10/19/2026</a:t>
+              <a:t>10/27/2026</a:t>
             </a:fld>
             <a:endParaRPr lang="en-US"/>
           </a:p>
@@ -5375,7 +5326,7 @@
           <a:p>
             <a:fld id="{8CF61943-3342-4554-8403-118C8C1529D5}" type="datetimeFigureOut">
               <a:rPr lang="en-US" smtClean="0"/>
-              <a:t>10/19/2026</a:t>
+              <a:t>10/27/2026</a:t>
             </a:fld>
             <a:endParaRPr lang="en-US"/>
           </a:p>
@@ -5623,128 +5574,6 @@
 </p:sldLayout>
 </file>
 
-<file path=ppt/slideLayouts/slideLayout3.xml><?xml version="1.0" encoding="utf-8"?>
-<p:sldLayout xmlns:a="http://schemas.openxmlformats.org/drawingml/2006/main" xmlns:r="http://schemas.openxmlformats.org/officeDocument/2006/relationships" xmlns:p="http://schemas.openxmlformats.org/presentationml/2006/main" type="obj">
-  <p:cSld name="Title and Content">
-    <p:spTree>
-      <p:nvGrpSpPr>
-        <p:cNvPr id="1" name=""/>
-        <p:cNvGrpSpPr/>
-        <p:nvPr/>
-      </p:nvGrpSpPr>
-      <p:grpSpPr>
-        <a:xfrm>
-          <a:off x="0" y="0"/>
-          <a:ext cx="0" cy="0"/>
-          <a:chOff x="0" y="0"/>
-          <a:chExt cx="0" cy="0"/>
-        </a:xfrm>
-      </p:grpSpPr>
-      <p:sp>
-        <p:nvSpPr>
-          <p:cNvPr id="2" name="Title 1"/>
-          <p:cNvSpPr>
-            <a:spLocks noGrp="1"/>
-          </p:cNvSpPr>
-          <p:nvPr>
-            <p:ph type="title"/>
-          </p:nvPr>
-        </p:nvSpPr>
-        <p:spPr/>
-        <p:txBody>
-          <a:bodyPr/>
-          <a:lstStyle/>
-          <a:p>
-            <a:r>
-              <a:rPr lang="en-US"/>
-              <a:t>Click to edit Master title style</a:t>
-            </a:r>
-          </a:p>
-        </p:txBody>
-      </p:sp>
-      <p:sp>
-        <p:nvSpPr>
-          <p:cNvPr id="3" name="Content Placeholder 2"/>
-          <p:cNvSpPr>
-            <a:spLocks noGrp="1"/>
-          </p:cNvSpPr>
-          <p:nvPr>
-            <p:ph idx="1"/>
-          </p:nvPr>
-        </p:nvSpPr>
-        <p:spPr/>
-        <p:txBody>
-          <a:bodyPr/>
-          <a:lstStyle>
-            <a:lvl1pPr>
-              <a:defRPr sz="2400"/>
-            </a:lvl1pPr>
-            <a:lvl2pPr>
-              <a:defRPr sz="2000"/>
-            </a:lvl2pPr>
-            <a:lvl3pPr>
-              <a:defRPr sz="1800"/>
-            </a:lvl3pPr>
-            <a:lvl4pPr>
-              <a:defRPr sz="1600"/>
-            </a:lvl4pPr>
-            <a:lvl5pPr>
-              <a:defRPr sz="1400"/>
-            </a:lvl5pPr>
-          </a:lstStyle>
-          <a:p>
-            <a:pPr lvl="0"/>
-            <a:r>
-              <a:rPr lang="en-US" dirty="0"/>
-              <a:t>Click to edit Master text styles</a:t>
-            </a:r>
-          </a:p>
-          <a:p>
-            <a:pPr lvl="1"/>
-            <a:r>
-              <a:rPr lang="en-US" dirty="0"/>
-              <a:t>Second level</a:t>
-            </a:r>
-          </a:p>
-          <a:p>
-            <a:pPr lvl="2"/>
-            <a:r>
-              <a:rPr lang="en-US" dirty="0"/>
-              <a:t>Third level</a:t>
-            </a:r>
-          </a:p>
-          <a:p>
-            <a:pPr lvl="3"/>
-            <a:r>
-              <a:rPr lang="en-US" dirty="0"/>
-              <a:t>Fourth level</a:t>
-            </a:r>
-          </a:p>
-          <a:p>
-            <a:pPr lvl="4"/>
-            <a:r>
-              <a:rPr lang="en-US" dirty="0"/>
-              <a:t>Fifth level</a:t>
-            </a:r>
-          </a:p>
-        </p:txBody>
-      </p:sp>
-    </p:spTree>
-    <p:extLst>
-      <p:ext uri="{BB962C8B-B14F-4D97-AF65-F5344CB8AC3E}">
-        <p14:creationId xmlns:p14="http://schemas.microsoft.com/office/powerpoint/2010/main" val="2132794513"/>
-      </p:ext>
-    </p:extLst>
-  </p:cSld>
-  <p:clrMapOvr>
-    <a:masterClrMapping/>
-  </p:clrMapOvr>
-  <p:transition>
-    <p:fade/>
-  </p:transition>
-</p:sldLayout>
-</file>
-
 <file path=ppt/slideMasters/slideMaster1.xml><?xml version="1.0" encoding="utf-8"?>
 <p:sldMaster xmlns:a="http://schemas.openxmlformats.org/drawingml/2006/main" xmlns:r="http://schemas.openxmlformats.org/officeDocument/2006/relationships" xmlns:p="http://schemas.openxmlformats.org/presentationml/2006/main" preserve="1">
   <p:cSld>
@@ -5913,7 +5742,7 @@
           <a:p>
             <a:fld id="{8CF61943-3342-4554-8403-118C8C1529D5}" type="datetimeFigureOut">
               <a:rPr lang="en-US" smtClean="0"/>
-              <a:t>10/19/2026</a:t>
+              <a:t>10/27/2026</a:t>
             </a:fld>
             <a:endParaRPr lang="en-US"/>
           </a:p>
@@ -6020,7 +5849,6 @@
   <p:sldLayoutIdLst>
     <p:sldLayoutId id="2147483709" r:id="rId1"/>
     <p:sldLayoutId id="2147483710" r:id="rId2"/>
-    <p:sldLayoutId id="2147483711" r:id="rId3"/>
   </p:sldLayoutIdLst>
   <p:txStyles>
     <p:titleStyle>
@@ -6884,3334 +6712,10 @@
 </p:sld>
 </file>
 
-<file path=ppt/slides/slide2.xml><?xml version="1.0" encoding="utf-8"?>
-<p:sld xmlns:a="http://schemas.openxmlformats.org/drawingml/2006/main" xmlns:r="http://schemas.openxmlformats.org/officeDocument/2006/relationships" xmlns:p="http://schemas.openxmlformats.org/presentationml/2006/main">
-  <p:cSld>
-    <p:spTree>
-      <p:nvGrpSpPr>
-        <p:cNvPr id="1" name=""/>
-        <p:cNvGrpSpPr/>
-        <p:nvPr/>
-      </p:nvGrpSpPr>
-      <p:grpSpPr>
-        <a:xfrm>
-          <a:off x="0" y="0"/>
-          <a:ext cx="0" cy="0"/>
-          <a:chOff x="0" y="0"/>
-          <a:chExt cx="0" cy="0"/>
-        </a:xfrm>
-      </p:grpSpPr>
-      <p:sp>
-        <p:nvSpPr>
-          <p:cNvPr id="2" name="Text Placeholder 1">
-            <a:extLst>
-              <a:ext uri="{FF2B5EF4-FFF2-40B4-BE49-F238E27FC236}">
-                <a16:creationId xmlns:a16="http://schemas.microsoft.com/office/drawing/2014/main" id="{168CC41A-92DC-4526-9165-E4D3020A5F9A}"/>
-              </a:ext>
-            </a:extLst>
-          </p:cNvPr>
-          <p:cNvSpPr>
-            <a:spLocks noGrp="1"/>
-          </p:cNvSpPr>
-          <p:nvPr>
-            <p:ph type="body" sz="quarter" idx="10"/>
-          </p:nvPr>
-        </p:nvSpPr>
-        <p:spPr/>
-        <p:txBody>
-          <a:bodyPr/>
-          <a:lstStyle/>
-          <a:p>
-            <a:r>
-              <a:rPr lang="en-US" dirty="0"/>
-              <a:t>Auto-ISAC ACT Advanced Wireless Lab – 2026 Syllabus</a:t>
-            </a:r>
-          </a:p>
-        </p:txBody>
-      </p:sp>
-      <p:sp>
-        <p:nvSpPr>
-          <p:cNvPr id="4" name="Text Placeholder 3">
-            <a:extLst>
-              <a:ext uri="{FF2B5EF4-FFF2-40B4-BE49-F238E27FC236}">
-                <a16:creationId xmlns:a16="http://schemas.microsoft.com/office/drawing/2014/main" id="{37CF222F-449F-AEF7-61FD-D75CFCD9EC5D}"/>
-              </a:ext>
-            </a:extLst>
-          </p:cNvPr>
-          <p:cNvSpPr>
-            <a:spLocks noGrp="1"/>
-          </p:cNvSpPr>
-          <p:nvPr>
-            <p:ph type="body" sz="quarter" idx="12"/>
-          </p:nvPr>
-        </p:nvSpPr>
-        <p:spPr>
-          <a:xfrm>
-            <a:off x="270415" y="717259"/>
-            <a:ext cx="11658059" cy="5848133"/>
-          </a:xfrm>
-        </p:spPr>
-        <p:txBody>
-          <a:bodyPr>
-            <a:normAutofit fontScale="92500" lnSpcReduction="20000"/>
-          </a:bodyPr>
-          <a:lstStyle/>
-          <a:p>
-            <a:pPr marL="285750" indent="-285750">
-              <a:buFont typeface="Arial" panose="020B0604020202020204" pitchFamily="34" charset="0"/>
-              <a:buChar char="•"/>
-            </a:pPr>
-            <a:r>
-              <a:rPr lang="en-US" sz="1600" b="1" dirty="0"/>
-              <a:t>Intro</a:t>
-            </a:r>
-          </a:p>
-          <a:p>
-            <a:pPr marL="971550" lvl="1" indent="-285750"/>
-            <a:r>
-              <a:rPr lang="en-US" sz="1400" dirty="0"/>
-              <a:t>US Laws &amp; Regulations</a:t>
-            </a:r>
-          </a:p>
-          <a:p>
-            <a:pPr marL="971550" lvl="1" indent="-285750"/>
-            <a:r>
-              <a:rPr lang="en-US" sz="1400" dirty="0"/>
-              <a:t>Radio Modulation</a:t>
-            </a:r>
-          </a:p>
-          <a:p>
-            <a:pPr marL="971550" lvl="1" indent="-285750"/>
-            <a:r>
-              <a:rPr lang="en-US" sz="1400" dirty="0"/>
-              <a:t>FCC ID Lookup</a:t>
-            </a:r>
-          </a:p>
-          <a:p>
-            <a:pPr marL="971550" lvl="1" indent="-285750"/>
-            <a:r>
-              <a:rPr lang="en-US" sz="1400" dirty="0"/>
-              <a:t>MAC ID Lookup</a:t>
-            </a:r>
-          </a:p>
-          <a:p>
-            <a:pPr marL="285750" indent="-285750">
-              <a:buFont typeface="Arial" panose="020B0604020202020204" pitchFamily="34" charset="0"/>
-              <a:buChar char="•"/>
-            </a:pPr>
-            <a:r>
-              <a:rPr lang="en-US" sz="1600" b="1" dirty="0"/>
-              <a:t>Bluetooth</a:t>
-            </a:r>
-          </a:p>
-          <a:p>
-            <a:pPr marL="971550" lvl="1" indent="-285750"/>
-            <a:r>
-              <a:rPr lang="en-US" sz="1400" dirty="0"/>
-              <a:t>Scanning</a:t>
-            </a:r>
-          </a:p>
-          <a:p>
-            <a:pPr marL="971550" lvl="1" indent="-285750"/>
-            <a:r>
-              <a:rPr lang="en-US" sz="1400" dirty="0"/>
-              <a:t>Enumerating</a:t>
-            </a:r>
-          </a:p>
-          <a:p>
-            <a:pPr marL="971550" lvl="1" indent="-285750"/>
-            <a:r>
-              <a:rPr lang="en-US" sz="1400" dirty="0"/>
-              <a:t>Identifying</a:t>
-            </a:r>
-          </a:p>
-          <a:p>
-            <a:pPr marL="971550" lvl="1" indent="-285750"/>
-            <a:r>
-              <a:rPr lang="en-US" sz="1400" dirty="0"/>
-              <a:t>Analyzing</a:t>
-            </a:r>
-          </a:p>
-          <a:p>
-            <a:pPr marL="971550" lvl="1" indent="-285750"/>
-            <a:r>
-              <a:rPr lang="en-US" sz="1400" dirty="0"/>
-              <a:t>Pairing</a:t>
-            </a:r>
-          </a:p>
-          <a:p>
-            <a:pPr marL="971550" lvl="1" indent="-285750"/>
-            <a:r>
-              <a:rPr lang="en-US" sz="1400" dirty="0"/>
-              <a:t>Data</a:t>
-            </a:r>
-          </a:p>
-          <a:p>
-            <a:pPr marL="285750" indent="-285750">
-              <a:buFont typeface="Arial" panose="020B0604020202020204" pitchFamily="34" charset="0"/>
-              <a:buChar char="•"/>
-            </a:pPr>
-            <a:r>
-              <a:rPr lang="en-US" sz="1600" b="1" dirty="0" err="1"/>
-              <a:t>WiFi</a:t>
-            </a:r>
-            <a:endParaRPr lang="en-US" sz="1600" b="1" dirty="0"/>
-          </a:p>
-          <a:p>
-            <a:pPr marL="971550" lvl="1" indent="-285750"/>
-            <a:r>
-              <a:rPr lang="en-US" sz="1400" dirty="0"/>
-              <a:t>Analyzer</a:t>
-            </a:r>
-          </a:p>
-          <a:p>
-            <a:pPr marL="971550" lvl="1" indent="-285750"/>
-            <a:r>
-              <a:rPr lang="en-US" sz="1400" dirty="0" err="1"/>
-              <a:t>WiFite</a:t>
-            </a:r>
-            <a:endParaRPr lang="en-US" sz="1400" dirty="0"/>
-          </a:p>
-          <a:p>
-            <a:pPr marL="971550" lvl="1" indent="-285750"/>
-            <a:r>
-              <a:rPr lang="en-US" sz="1400" dirty="0" err="1"/>
-              <a:t>HackISAC</a:t>
-            </a:r>
-            <a:endParaRPr lang="en-US" sz="1400" dirty="0"/>
-          </a:p>
-          <a:p>
-            <a:pPr marL="285750" indent="-285750">
-              <a:buFont typeface="Arial" panose="020B0604020202020204" pitchFamily="34" charset="0"/>
-              <a:buChar char="•"/>
-            </a:pPr>
-            <a:r>
-              <a:rPr lang="en-US" sz="1600" b="1" dirty="0"/>
-              <a:t>GPS</a:t>
-            </a:r>
-          </a:p>
-          <a:p>
-            <a:pPr marL="971550" lvl="1" indent="-285750"/>
-            <a:r>
-              <a:rPr lang="en-US" sz="1400" dirty="0"/>
-              <a:t>Viewing</a:t>
-            </a:r>
-            <a:endParaRPr lang="en-US" sz="800" dirty="0"/>
-          </a:p>
-          <a:p>
-            <a:pPr marL="285750" indent="-285750">
-              <a:buFont typeface="Arial" panose="020B0604020202020204" pitchFamily="34" charset="0"/>
-              <a:buChar char="•"/>
-            </a:pPr>
-            <a:r>
-              <a:rPr lang="en-US" sz="1600" b="1" dirty="0"/>
-              <a:t>Cellular</a:t>
-            </a:r>
-          </a:p>
-          <a:p>
-            <a:pPr marL="971550" lvl="1" indent="-285750"/>
-            <a:r>
-              <a:rPr lang="en-US" sz="1400" dirty="0"/>
-              <a:t>Overview</a:t>
-            </a:r>
-            <a:endParaRPr lang="en-US" sz="1400" b="1" dirty="0"/>
-          </a:p>
-          <a:p>
-            <a:pPr marL="285750" indent="-285750">
-              <a:buFont typeface="Arial" panose="020B0604020202020204" pitchFamily="34" charset="0"/>
-              <a:buChar char="•"/>
-            </a:pPr>
-            <a:r>
-              <a:rPr lang="en-US" sz="1600" b="1" dirty="0"/>
-              <a:t>SDR</a:t>
-            </a:r>
-          </a:p>
-          <a:p>
-            <a:pPr marL="971550" lvl="1" indent="-285750"/>
-            <a:r>
-              <a:rPr lang="en-US" sz="1400" dirty="0"/>
-              <a:t>FM Radio</a:t>
-            </a:r>
-          </a:p>
-          <a:p>
-            <a:pPr marL="971550" lvl="1" indent="-285750"/>
-            <a:r>
-              <a:rPr lang="en-US" sz="1400" dirty="0" err="1"/>
-              <a:t>Keyfob</a:t>
-            </a:r>
-            <a:r>
-              <a:rPr lang="en-US" sz="1400" dirty="0"/>
-              <a:t> record</a:t>
-            </a:r>
-          </a:p>
-          <a:p>
-            <a:pPr marL="971550" lvl="1" indent="-285750"/>
-            <a:r>
-              <a:rPr lang="en-US" sz="1400" dirty="0" err="1"/>
-              <a:t>Keyfob</a:t>
-            </a:r>
-            <a:r>
-              <a:rPr lang="en-US" sz="1400" dirty="0"/>
-              <a:t> replay</a:t>
-            </a:r>
-          </a:p>
-          <a:p>
-            <a:pPr marL="971550" lvl="1" indent="-285750"/>
-            <a:r>
-              <a:rPr lang="en-US" sz="1400" dirty="0" err="1"/>
-              <a:t>Keyfob</a:t>
-            </a:r>
-            <a:r>
-              <a:rPr lang="en-US" sz="1400" dirty="0"/>
-              <a:t> decode</a:t>
-            </a:r>
-          </a:p>
-          <a:p>
-            <a:pPr marL="285750" indent="-285750"/>
-            <a:endParaRPr lang="en-US" sz="800" dirty="0"/>
-          </a:p>
-        </p:txBody>
-      </p:sp>
-    </p:spTree>
-    <p:extLst>
-      <p:ext uri="{BB962C8B-B14F-4D97-AF65-F5344CB8AC3E}">
-        <p14:creationId xmlns:p14="http://schemas.microsoft.com/office/powerpoint/2010/main" val="1194985742"/>
-      </p:ext>
-    </p:extLst>
-  </p:cSld>
-  <p:clrMapOvr>
-    <a:masterClrMapping/>
-  </p:clrMapOvr>
-</p:sld>
-</file>
-
-<file path=ppt/slides/slide3.xml><?xml version="1.0" encoding="utf-8"?>
-<p:sld xmlns:a="http://schemas.openxmlformats.org/drawingml/2006/main" xmlns:r="http://schemas.openxmlformats.org/officeDocument/2006/relationships" xmlns:p="http://schemas.openxmlformats.org/presentationml/2006/main">
-  <p:cSld>
-    <p:spTree>
-      <p:nvGrpSpPr>
-        <p:cNvPr id="1" name=""/>
-        <p:cNvGrpSpPr/>
-        <p:nvPr/>
-      </p:nvGrpSpPr>
-      <p:grpSpPr>
-        <a:xfrm>
-          <a:off x="0" y="0"/>
-          <a:ext cx="0" cy="0"/>
-          <a:chOff x="0" y="0"/>
-          <a:chExt cx="0" cy="0"/>
-        </a:xfrm>
-      </p:grpSpPr>
-      <p:sp>
-        <p:nvSpPr>
-          <p:cNvPr id="2" name="Title 1"/>
-          <p:cNvSpPr>
-            <a:spLocks noGrp="1"/>
-          </p:cNvSpPr>
-          <p:nvPr>
-            <p:ph type="title"/>
-          </p:nvPr>
-        </p:nvSpPr>
-        <p:spPr>
-          <a:xfrm>
-            <a:off x="1981200" y="274638"/>
-            <a:ext cx="8229600" cy="698304"/>
-          </a:xfrm>
-        </p:spPr>
-        <p:txBody>
-          <a:bodyPr>
-            <a:normAutofit fontScale="90000"/>
-          </a:bodyPr>
-          <a:lstStyle/>
-          <a:p>
-            <a:pPr algn="ctr"/>
-            <a:r>
-              <a:rPr lang="en-US" b="1" dirty="0"/>
-              <a:t>US Laws, Guidelines &amp; Rules</a:t>
-            </a:r>
-          </a:p>
-        </p:txBody>
-      </p:sp>
-      <p:sp>
-        <p:nvSpPr>
-          <p:cNvPr id="3" name="Content Placeholder 2"/>
-          <p:cNvSpPr>
-            <a:spLocks noGrp="1"/>
-          </p:cNvSpPr>
-          <p:nvPr>
-            <p:ph idx="1"/>
-          </p:nvPr>
-        </p:nvSpPr>
-        <p:spPr>
-          <a:xfrm>
-            <a:off x="1981200" y="900706"/>
-            <a:ext cx="8229600" cy="5562248"/>
-          </a:xfrm>
-        </p:spPr>
-        <p:txBody>
-          <a:bodyPr>
-            <a:normAutofit fontScale="92500" lnSpcReduction="10000"/>
-          </a:bodyPr>
-          <a:lstStyle/>
-          <a:p>
-            <a:r>
-              <a:rPr lang="en-US" dirty="0"/>
-              <a:t>FCC</a:t>
-            </a:r>
-          </a:p>
-          <a:p>
-            <a:pPr lvl="1"/>
-            <a:r>
-              <a:rPr lang="en-US" dirty="0"/>
-              <a:t>General Radio</a:t>
-            </a:r>
-          </a:p>
-          <a:p>
-            <a:pPr lvl="2"/>
-            <a:r>
-              <a:rPr lang="en-US" dirty="0">
-                <a:hlinkClick r:id="rId2"/>
-              </a:rPr>
-              <a:t>https://www.fcc.gov/media/radio/low-power-radio-general-information</a:t>
-            </a:r>
-            <a:endParaRPr lang="en-US" dirty="0"/>
-          </a:p>
-          <a:p>
-            <a:pPr lvl="1"/>
-            <a:r>
-              <a:rPr lang="en-US" dirty="0"/>
-              <a:t>Spectrum Allocation</a:t>
-            </a:r>
-          </a:p>
-          <a:p>
-            <a:pPr lvl="2"/>
-            <a:r>
-              <a:rPr lang="en-US" dirty="0"/>
-              <a:t>Many of the devices mentioned use unlicensed bands</a:t>
-            </a:r>
-          </a:p>
-          <a:p>
-            <a:pPr lvl="2"/>
-            <a:r>
-              <a:rPr lang="en-US" dirty="0">
-                <a:hlinkClick r:id="rId3"/>
-              </a:rPr>
-              <a:t>https://www.fcc.gov/engineering-technology/policy-and-rules-division/general/radio-spectrum-allocation</a:t>
-            </a:r>
-            <a:endParaRPr lang="en-US" dirty="0"/>
-          </a:p>
-          <a:p>
-            <a:pPr lvl="1"/>
-            <a:r>
-              <a:rPr lang="en-US" dirty="0"/>
-              <a:t>Unauthorized Radio Operation</a:t>
-            </a:r>
-          </a:p>
-          <a:p>
-            <a:pPr lvl="2"/>
-            <a:r>
-              <a:rPr lang="en-US" dirty="0"/>
-              <a:t>There are restrictions on band usage and power levels</a:t>
-            </a:r>
-          </a:p>
-          <a:p>
-            <a:pPr lvl="2"/>
-            <a:r>
-              <a:rPr lang="en-US" dirty="0"/>
-              <a:t>Violation of these rules are against the law</a:t>
-            </a:r>
-          </a:p>
-          <a:p>
-            <a:pPr lvl="2"/>
-            <a:r>
-              <a:rPr lang="en-US" dirty="0">
-                <a:hlinkClick r:id="rId4"/>
-              </a:rPr>
-              <a:t>https://www.fcc.gov/consumers/guides/unauthorized-radio-operation</a:t>
-            </a:r>
-            <a:endParaRPr lang="en-US" dirty="0"/>
-          </a:p>
-          <a:p>
-            <a:pPr lvl="1"/>
-            <a:r>
-              <a:rPr lang="en-US" dirty="0"/>
-              <a:t>Jammer Enforcement</a:t>
-            </a:r>
-          </a:p>
-          <a:p>
-            <a:pPr lvl="2"/>
-            <a:r>
-              <a:rPr lang="en-US" dirty="0"/>
-              <a:t>Jammers are against the law</a:t>
-            </a:r>
-          </a:p>
-          <a:p>
-            <a:pPr lvl="2"/>
-            <a:r>
-              <a:rPr lang="en-US" dirty="0">
-                <a:hlinkClick r:id="rId5"/>
-              </a:rPr>
-              <a:t>https://www.fcc.gov/general/jammer-enforcement</a:t>
-            </a:r>
-            <a:endParaRPr lang="en-US" dirty="0"/>
-          </a:p>
-          <a:p>
-            <a:pPr lvl="1"/>
-            <a:r>
-              <a:rPr lang="en-US" dirty="0"/>
-              <a:t>Device Lookup</a:t>
-            </a:r>
-          </a:p>
-          <a:p>
-            <a:pPr lvl="2"/>
-            <a:r>
-              <a:rPr lang="en-US" dirty="0"/>
-              <a:t>Transmitting Devices in the US must be FCC certified and labeled</a:t>
-            </a:r>
-          </a:p>
-          <a:p>
-            <a:pPr lvl="2"/>
-            <a:r>
-              <a:rPr lang="en-US" dirty="0">
-                <a:hlinkClick r:id="rId6"/>
-              </a:rPr>
-              <a:t>https://www.fcc.gov/oet/ea/fccid</a:t>
-            </a:r>
-            <a:endParaRPr lang="en-US" dirty="0"/>
-          </a:p>
-          <a:p>
-            <a:pPr lvl="2"/>
-            <a:r>
-              <a:rPr lang="en-US" dirty="0">
-                <a:hlinkClick r:id="rId7"/>
-              </a:rPr>
-              <a:t>https://fccid.io/</a:t>
-            </a:r>
-            <a:endParaRPr lang="en-US" dirty="0"/>
-          </a:p>
-          <a:p>
-            <a:pPr lvl="2"/>
-            <a:r>
-              <a:rPr lang="en-US" dirty="0"/>
-              <a:t>Useful for obtaining additional information on wireless devices</a:t>
-            </a:r>
-          </a:p>
-          <a:p>
-            <a:pPr marL="914400" lvl="2" indent="0">
-              <a:buNone/>
-            </a:pPr>
-            <a:endParaRPr lang="en-US" dirty="0"/>
-          </a:p>
-        </p:txBody>
-      </p:sp>
-    </p:spTree>
-    <p:extLst>
-      <p:ext uri="{BB962C8B-B14F-4D97-AF65-F5344CB8AC3E}">
-        <p14:creationId xmlns:p14="http://schemas.microsoft.com/office/powerpoint/2010/main" val="4007756786"/>
-      </p:ext>
-    </p:extLst>
-  </p:cSld>
-  <p:clrMapOvr>
-    <a:masterClrMapping/>
-  </p:clrMapOvr>
-  <p:transition>
-    <p:fade/>
-  </p:transition>
-</p:sld>
-</file>
-
-<file path=ppt/slides/slide4.xml><?xml version="1.0" encoding="utf-8"?>
-<p:sld xmlns:a="http://schemas.openxmlformats.org/drawingml/2006/main" xmlns:r="http://schemas.openxmlformats.org/officeDocument/2006/relationships" xmlns:p="http://schemas.openxmlformats.org/presentationml/2006/main">
-  <p:cSld>
-    <p:spTree>
-      <p:nvGrpSpPr>
-        <p:cNvPr id="1" name=""/>
-        <p:cNvGrpSpPr/>
-        <p:nvPr/>
-      </p:nvGrpSpPr>
-      <p:grpSpPr>
-        <a:xfrm>
-          <a:off x="0" y="0"/>
-          <a:ext cx="0" cy="0"/>
-          <a:chOff x="0" y="0"/>
-          <a:chExt cx="0" cy="0"/>
-        </a:xfrm>
-      </p:grpSpPr>
-      <p:pic>
-        <p:nvPicPr>
-          <p:cNvPr id="4" name="Picture 3" descr="Radio Modulation Explained: Carrier Changes and Sidebands | Dahiru Ohida  posted on the topic | LinkedIn">
-            <a:extLst>
-              <a:ext uri="{FF2B5EF4-FFF2-40B4-BE49-F238E27FC236}">
-                <a16:creationId xmlns:a16="http://schemas.microsoft.com/office/drawing/2014/main" id="{2DE009B5-8E18-E8D1-5552-5F4FAAEF0916}"/>
-              </a:ext>
-            </a:extLst>
-          </p:cNvPr>
-          <p:cNvPicPr>
-            <a:picLocks noChangeAspect="1"/>
-          </p:cNvPicPr>
-          <p:nvPr/>
-        </p:nvPicPr>
-        <p:blipFill>
-          <a:blip r:embed="rId2"/>
-          <a:stretch>
-            <a:fillRect/>
-          </a:stretch>
-        </p:blipFill>
-        <p:spPr>
-          <a:xfrm>
-            <a:off x="219074" y="96821"/>
-            <a:ext cx="5305425" cy="6664358"/>
-          </a:xfrm>
-          <a:prstGeom prst="rect">
-            <a:avLst/>
-          </a:prstGeom>
-        </p:spPr>
-      </p:pic>
-      <p:pic>
-        <p:nvPicPr>
-          <p:cNvPr id="5" name="Picture 4" descr="Waterfall Displays—What Information Do They Provide?">
-            <a:extLst>
-              <a:ext uri="{FF2B5EF4-FFF2-40B4-BE49-F238E27FC236}">
-                <a16:creationId xmlns:a16="http://schemas.microsoft.com/office/drawing/2014/main" id="{F2929E58-5667-CD8A-B800-D0C6DDE7C602}"/>
-              </a:ext>
-            </a:extLst>
-          </p:cNvPr>
-          <p:cNvPicPr>
-            <a:picLocks noChangeAspect="1"/>
-          </p:cNvPicPr>
-          <p:nvPr/>
-        </p:nvPicPr>
-        <p:blipFill>
-          <a:blip r:embed="rId3"/>
-          <a:stretch>
-            <a:fillRect/>
-          </a:stretch>
-        </p:blipFill>
-        <p:spPr>
-          <a:xfrm>
-            <a:off x="6239158" y="495667"/>
-            <a:ext cx="4533333" cy="2933333"/>
-          </a:xfrm>
-          <a:prstGeom prst="rect">
-            <a:avLst/>
-          </a:prstGeom>
-        </p:spPr>
-      </p:pic>
-    </p:spTree>
-    <p:extLst>
-      <p:ext uri="{BB962C8B-B14F-4D97-AF65-F5344CB8AC3E}">
-        <p14:creationId xmlns:p14="http://schemas.microsoft.com/office/powerpoint/2010/main" val="717310136"/>
-      </p:ext>
-    </p:extLst>
-  </p:cSld>
-  <p:clrMapOvr>
-    <a:masterClrMapping/>
-  </p:clrMapOvr>
-  <p:transition>
-    <p:fade/>
-  </p:transition>
-</p:sld>
-</file>
-
-<file path=ppt/slides/slide5.xml><?xml version="1.0" encoding="utf-8"?>
-<p:sld xmlns:a="http://schemas.openxmlformats.org/drawingml/2006/main" xmlns:r="http://schemas.openxmlformats.org/officeDocument/2006/relationships" xmlns:p="http://schemas.openxmlformats.org/presentationml/2006/main" showMasterSp="0">
-  <p:cSld>
-    <p:spTree>
-      <p:nvGrpSpPr>
-        <p:cNvPr id="1" name=""/>
-        <p:cNvGrpSpPr/>
-        <p:nvPr/>
-      </p:nvGrpSpPr>
-      <p:grpSpPr>
-        <a:xfrm>
-          <a:off x="0" y="0"/>
-          <a:ext cx="0" cy="0"/>
-          <a:chOff x="0" y="0"/>
-          <a:chExt cx="0" cy="0"/>
-        </a:xfrm>
-      </p:grpSpPr>
-      <p:sp>
-        <p:nvSpPr>
-          <p:cNvPr id="2" name="object 2" descr="$PPTXTitle"/>
-          <p:cNvSpPr txBox="1"/>
-          <p:nvPr/>
-        </p:nvSpPr>
-        <p:spPr>
-          <a:xfrm>
-            <a:off x="398667" y="509412"/>
-            <a:ext cx="5933440" cy="632651"/>
-          </a:xfrm>
-          <a:prstGeom prst="rect">
-            <a:avLst/>
-          </a:prstGeom>
-        </p:spPr>
-        <p:txBody>
-          <a:bodyPr vert="horz" wrap="square" lIns="0" tIns="16933" rIns="0" bIns="0" rtlCol="0">
-            <a:spAutoFit/>
-          </a:bodyPr>
-          <a:lstStyle/>
-          <a:p>
-            <a:pPr marL="16933" defTabSz="1219170">
-              <a:spcBef>
-                <a:spcPts val="133"/>
-              </a:spcBef>
-            </a:pPr>
-            <a:r>
-              <a:rPr sz="4000" kern="0" dirty="0">
-                <a:solidFill>
-                  <a:srgbClr val="595959"/>
-                </a:solidFill>
-                <a:latin typeface="Roboto"/>
-                <a:cs typeface="Roboto"/>
-              </a:rPr>
-              <a:t>FCCID</a:t>
-            </a:r>
-            <a:r>
-              <a:rPr sz="4000" kern="0" spc="-80" dirty="0">
-                <a:solidFill>
-                  <a:srgbClr val="595959"/>
-                </a:solidFill>
-                <a:latin typeface="Roboto"/>
-                <a:cs typeface="Roboto"/>
-              </a:rPr>
-              <a:t> </a:t>
-            </a:r>
-            <a:r>
-              <a:rPr sz="4000" kern="0" dirty="0">
-                <a:solidFill>
-                  <a:srgbClr val="595959"/>
-                </a:solidFill>
-                <a:latin typeface="Roboto"/>
-                <a:cs typeface="Roboto"/>
-              </a:rPr>
-              <a:t>Lookup</a:t>
-            </a:r>
-            <a:r>
-              <a:rPr sz="4000" kern="0" spc="-60" dirty="0">
-                <a:solidFill>
-                  <a:srgbClr val="595959"/>
-                </a:solidFill>
-                <a:latin typeface="Roboto"/>
-                <a:cs typeface="Roboto"/>
-              </a:rPr>
-              <a:t> </a:t>
-            </a:r>
-            <a:r>
-              <a:rPr sz="4000" kern="0" dirty="0">
-                <a:solidFill>
-                  <a:srgbClr val="2A3890"/>
-                </a:solidFill>
-                <a:latin typeface="Roboto"/>
-                <a:cs typeface="Roboto"/>
-              </a:rPr>
-              <a:t>–</a:t>
-            </a:r>
-            <a:r>
-              <a:rPr sz="4000" kern="0" spc="-80" dirty="0">
-                <a:solidFill>
-                  <a:srgbClr val="2A3890"/>
-                </a:solidFill>
-                <a:latin typeface="Roboto"/>
-                <a:cs typeface="Roboto"/>
-              </a:rPr>
-              <a:t> </a:t>
-            </a:r>
-            <a:r>
-              <a:rPr sz="4000" kern="0" spc="-13" dirty="0">
-                <a:solidFill>
-                  <a:srgbClr val="2A3890"/>
-                </a:solidFill>
-                <a:latin typeface="Roboto"/>
-                <a:cs typeface="Roboto"/>
-              </a:rPr>
-              <a:t>Research</a:t>
-            </a:r>
-            <a:endParaRPr sz="4000" kern="0">
-              <a:solidFill>
-                <a:sysClr val="windowText" lastClr="000000"/>
-              </a:solidFill>
-              <a:latin typeface="Roboto"/>
-              <a:cs typeface="Roboto"/>
-            </a:endParaRPr>
-          </a:p>
-        </p:txBody>
-      </p:sp>
-      <p:grpSp>
-        <p:nvGrpSpPr>
-          <p:cNvPr id="3" name="object 3"/>
-          <p:cNvGrpSpPr/>
-          <p:nvPr/>
-        </p:nvGrpSpPr>
-        <p:grpSpPr>
-          <a:xfrm>
-            <a:off x="791449" y="1292220"/>
-            <a:ext cx="2337647" cy="4785360"/>
-            <a:chOff x="593586" y="969165"/>
-            <a:chExt cx="1753235" cy="3589020"/>
-          </a:xfrm>
-        </p:grpSpPr>
-        <p:pic>
-          <p:nvPicPr>
-            <p:cNvPr id="4" name="object 4"/>
-            <p:cNvPicPr/>
-            <p:nvPr/>
-          </p:nvPicPr>
-          <p:blipFill>
-            <a:blip r:embed="rId3" cstate="email">
-              <a:extLst>
-                <a:ext uri="{28A0092B-C50C-407E-A947-70E740481C1C}">
-                  <a14:useLocalDpi xmlns:a14="http://schemas.microsoft.com/office/drawing/2010/main"/>
-                </a:ext>
-              </a:extLst>
-            </a:blip>
-            <a:stretch>
-              <a:fillRect/>
-            </a:stretch>
-          </p:blipFill>
-          <p:spPr>
-            <a:xfrm>
-              <a:off x="745021" y="1049646"/>
-              <a:ext cx="1490060" cy="3334896"/>
-            </a:xfrm>
-            <a:prstGeom prst="rect">
-              <a:avLst/>
-            </a:prstGeom>
-          </p:spPr>
-        </p:pic>
-        <p:sp>
-          <p:nvSpPr>
-            <p:cNvPr id="5" name="object 5"/>
-            <p:cNvSpPr/>
-            <p:nvPr/>
-          </p:nvSpPr>
-          <p:spPr>
-            <a:xfrm>
-              <a:off x="598348" y="973928"/>
-              <a:ext cx="1743710" cy="3579495"/>
-            </a:xfrm>
-            <a:custGeom>
-              <a:avLst/>
-              <a:gdLst/>
-              <a:ahLst/>
-              <a:cxnLst/>
-              <a:rect l="l" t="t" r="r" b="b"/>
-              <a:pathLst>
-                <a:path w="1743710" h="3579495">
-                  <a:moveTo>
-                    <a:pt x="0" y="0"/>
-                  </a:moveTo>
-                  <a:lnTo>
-                    <a:pt x="1743493" y="0"/>
-                  </a:lnTo>
-                  <a:lnTo>
-                    <a:pt x="1743493" y="3579460"/>
-                  </a:lnTo>
-                  <a:lnTo>
-                    <a:pt x="0" y="3579460"/>
-                  </a:lnTo>
-                  <a:lnTo>
-                    <a:pt x="0" y="0"/>
-                  </a:lnTo>
-                  <a:close/>
-                </a:path>
-              </a:pathLst>
-            </a:custGeom>
-            <a:ln w="9524">
-              <a:solidFill>
-                <a:srgbClr val="212D73"/>
-              </a:solidFill>
-            </a:ln>
-          </p:spPr>
-          <p:txBody>
-            <a:bodyPr wrap="square" lIns="0" tIns="0" rIns="0" bIns="0" rtlCol="0"/>
-            <a:lstStyle/>
-            <a:p>
-              <a:pPr defTabSz="1219170"/>
-              <a:endParaRPr sz="2400" kern="0">
-                <a:solidFill>
-                  <a:sysClr val="windowText" lastClr="000000"/>
-                </a:solidFill>
-              </a:endParaRPr>
-            </a:p>
-          </p:txBody>
-        </p:sp>
-      </p:grpSp>
-      <p:grpSp>
-        <p:nvGrpSpPr>
-          <p:cNvPr id="6" name="object 6"/>
-          <p:cNvGrpSpPr/>
-          <p:nvPr/>
-        </p:nvGrpSpPr>
-        <p:grpSpPr>
-          <a:xfrm>
-            <a:off x="3669344" y="1292220"/>
-            <a:ext cx="2101427" cy="4785360"/>
-            <a:chOff x="2752008" y="969165"/>
-            <a:chExt cx="1576070" cy="3589020"/>
-          </a:xfrm>
-        </p:grpSpPr>
-        <p:pic>
-          <p:nvPicPr>
-            <p:cNvPr id="7" name="object 7"/>
-            <p:cNvPicPr/>
-            <p:nvPr/>
-          </p:nvPicPr>
-          <p:blipFill>
-            <a:blip r:embed="rId4" cstate="email">
-              <a:extLst>
-                <a:ext uri="{28A0092B-C50C-407E-A947-70E740481C1C}">
-                  <a14:useLocalDpi xmlns:a14="http://schemas.microsoft.com/office/drawing/2010/main"/>
-                </a:ext>
-              </a:extLst>
-            </a:blip>
-            <a:stretch>
-              <a:fillRect/>
-            </a:stretch>
-          </p:blipFill>
-          <p:spPr>
-            <a:xfrm>
-              <a:off x="2832489" y="978690"/>
-              <a:ext cx="1419104" cy="3476806"/>
-            </a:xfrm>
-            <a:prstGeom prst="rect">
-              <a:avLst/>
-            </a:prstGeom>
-          </p:spPr>
-        </p:pic>
-        <p:sp>
-          <p:nvSpPr>
-            <p:cNvPr id="8" name="object 8"/>
-            <p:cNvSpPr/>
-            <p:nvPr/>
-          </p:nvSpPr>
-          <p:spPr>
-            <a:xfrm>
-              <a:off x="2756771" y="973928"/>
-              <a:ext cx="1566545" cy="3579495"/>
-            </a:xfrm>
-            <a:custGeom>
-              <a:avLst/>
-              <a:gdLst/>
-              <a:ahLst/>
-              <a:cxnLst/>
-              <a:rect l="l" t="t" r="r" b="b"/>
-              <a:pathLst>
-                <a:path w="1566545" h="3579495">
-                  <a:moveTo>
-                    <a:pt x="0" y="0"/>
-                  </a:moveTo>
-                  <a:lnTo>
-                    <a:pt x="1566105" y="0"/>
-                  </a:lnTo>
-                  <a:lnTo>
-                    <a:pt x="1566105" y="3579460"/>
-                  </a:lnTo>
-                  <a:lnTo>
-                    <a:pt x="0" y="3579460"/>
-                  </a:lnTo>
-                  <a:lnTo>
-                    <a:pt x="0" y="0"/>
-                  </a:lnTo>
-                  <a:close/>
-                </a:path>
-              </a:pathLst>
-            </a:custGeom>
-            <a:ln w="9524">
-              <a:solidFill>
-                <a:srgbClr val="212D73"/>
-              </a:solidFill>
-            </a:ln>
-          </p:spPr>
-          <p:txBody>
-            <a:bodyPr wrap="square" lIns="0" tIns="0" rIns="0" bIns="0" rtlCol="0"/>
-            <a:lstStyle/>
-            <a:p>
-              <a:pPr defTabSz="1219170"/>
-              <a:endParaRPr sz="2400" kern="0">
-                <a:solidFill>
-                  <a:sysClr val="windowText" lastClr="000000"/>
-                </a:solidFill>
-              </a:endParaRPr>
-            </a:p>
-          </p:txBody>
-        </p:sp>
-      </p:grpSp>
-      <p:grpSp>
-        <p:nvGrpSpPr>
-          <p:cNvPr id="9" name="object 9"/>
-          <p:cNvGrpSpPr/>
-          <p:nvPr/>
-        </p:nvGrpSpPr>
-        <p:grpSpPr>
-          <a:xfrm>
-            <a:off x="6158684" y="2116186"/>
-            <a:ext cx="5779347" cy="2810933"/>
-            <a:chOff x="4619013" y="1587139"/>
-            <a:chExt cx="4334510" cy="2108200"/>
-          </a:xfrm>
-        </p:grpSpPr>
-        <p:pic>
-          <p:nvPicPr>
-            <p:cNvPr id="10" name="object 10"/>
-            <p:cNvPicPr/>
-            <p:nvPr/>
-          </p:nvPicPr>
-          <p:blipFill>
-            <a:blip r:embed="rId5" cstate="email">
-              <a:extLst>
-                <a:ext uri="{28A0092B-C50C-407E-A947-70E740481C1C}">
-                  <a14:useLocalDpi xmlns:a14="http://schemas.microsoft.com/office/drawing/2010/main"/>
-                </a:ext>
-              </a:extLst>
-            </a:blip>
-            <a:stretch>
-              <a:fillRect/>
-            </a:stretch>
-          </p:blipFill>
-          <p:spPr>
-            <a:xfrm>
-              <a:off x="4628538" y="1596664"/>
-              <a:ext cx="4315358" cy="2033148"/>
-            </a:xfrm>
-            <a:prstGeom prst="rect">
-              <a:avLst/>
-            </a:prstGeom>
-          </p:spPr>
-        </p:pic>
-        <p:sp>
-          <p:nvSpPr>
-            <p:cNvPr id="11" name="object 11"/>
-            <p:cNvSpPr/>
-            <p:nvPr/>
-          </p:nvSpPr>
-          <p:spPr>
-            <a:xfrm>
-              <a:off x="4623775" y="1591901"/>
-              <a:ext cx="4324985" cy="2098675"/>
-            </a:xfrm>
-            <a:custGeom>
-              <a:avLst/>
-              <a:gdLst/>
-              <a:ahLst/>
-              <a:cxnLst/>
-              <a:rect l="l" t="t" r="r" b="b"/>
-              <a:pathLst>
-                <a:path w="4324984" h="2098675">
-                  <a:moveTo>
-                    <a:pt x="0" y="0"/>
-                  </a:moveTo>
-                  <a:lnTo>
-                    <a:pt x="4324883" y="0"/>
-                  </a:lnTo>
-                  <a:lnTo>
-                    <a:pt x="4324883" y="2098585"/>
-                  </a:lnTo>
-                  <a:lnTo>
-                    <a:pt x="0" y="2098585"/>
-                  </a:lnTo>
-                  <a:lnTo>
-                    <a:pt x="0" y="0"/>
-                  </a:lnTo>
-                  <a:close/>
-                </a:path>
-              </a:pathLst>
-            </a:custGeom>
-            <a:ln w="9524">
-              <a:solidFill>
-                <a:srgbClr val="212D73"/>
-              </a:solidFill>
-            </a:ln>
-          </p:spPr>
-          <p:txBody>
-            <a:bodyPr wrap="square" lIns="0" tIns="0" rIns="0" bIns="0" rtlCol="0"/>
-            <a:lstStyle/>
-            <a:p>
-              <a:pPr defTabSz="1219170"/>
-              <a:endParaRPr sz="2400" kern="0">
-                <a:solidFill>
-                  <a:sysClr val="windowText" lastClr="000000"/>
-                </a:solidFill>
-              </a:endParaRPr>
-            </a:p>
-          </p:txBody>
-        </p:sp>
-      </p:grpSp>
-      <p:sp>
-        <p:nvSpPr>
-          <p:cNvPr id="12" name="object 12"/>
-          <p:cNvSpPr txBox="1"/>
-          <p:nvPr/>
-        </p:nvSpPr>
-        <p:spPr>
-          <a:xfrm>
-            <a:off x="6243370" y="1756718"/>
-            <a:ext cx="2613660" cy="304421"/>
-          </a:xfrm>
-          <a:prstGeom prst="rect">
-            <a:avLst/>
-          </a:prstGeom>
-        </p:spPr>
-        <p:txBody>
-          <a:bodyPr vert="horz" wrap="square" lIns="0" tIns="16933" rIns="0" bIns="0" rtlCol="0">
-            <a:spAutoFit/>
-          </a:bodyPr>
-          <a:lstStyle/>
-          <a:p>
-            <a:pPr marL="16933" defTabSz="1219170">
-              <a:spcBef>
-                <a:spcPts val="133"/>
-              </a:spcBef>
-            </a:pPr>
-            <a:r>
-              <a:rPr sz="1867" b="1" kern="0" dirty="0">
-                <a:solidFill>
-                  <a:srgbClr val="2A3890"/>
-                </a:solidFill>
-                <a:latin typeface="Arial"/>
-                <a:cs typeface="Arial"/>
-              </a:rPr>
-              <a:t>Operating</a:t>
-            </a:r>
-            <a:r>
-              <a:rPr sz="1867" b="1" kern="0" spc="-60" dirty="0">
-                <a:solidFill>
-                  <a:srgbClr val="2A3890"/>
-                </a:solidFill>
-                <a:latin typeface="Arial"/>
-                <a:cs typeface="Arial"/>
-              </a:rPr>
-              <a:t> </a:t>
-            </a:r>
-            <a:r>
-              <a:rPr sz="1867" b="1" kern="0" spc="-13" dirty="0">
-                <a:solidFill>
-                  <a:srgbClr val="2A3890"/>
-                </a:solidFill>
-                <a:latin typeface="Arial"/>
-                <a:cs typeface="Arial"/>
-              </a:rPr>
-              <a:t>Frequencies</a:t>
-            </a:r>
-            <a:endParaRPr sz="1867" kern="0">
-              <a:solidFill>
-                <a:sysClr val="windowText" lastClr="000000"/>
-              </a:solidFill>
-              <a:latin typeface="Arial"/>
-              <a:cs typeface="Arial"/>
-            </a:endParaRPr>
-          </a:p>
-        </p:txBody>
-      </p:sp>
-      <p:sp>
-        <p:nvSpPr>
-          <p:cNvPr id="13" name="object 13"/>
-          <p:cNvSpPr txBox="1">
-            <a:spLocks noGrp="1"/>
-          </p:cNvSpPr>
-          <p:nvPr>
-            <p:ph type="sldNum" sz="quarter" idx="12"/>
-          </p:nvPr>
-        </p:nvSpPr>
-        <p:spPr>
-          <a:prstGeom prst="rect">
-            <a:avLst/>
-          </a:prstGeom>
-        </p:spPr>
-        <p:txBody>
-          <a:bodyPr vert="horz" wrap="square" lIns="0" tIns="0" rIns="0" bIns="0" rtlCol="0">
-            <a:spAutoFit/>
-          </a:bodyPr>
-          <a:lstStyle/>
-          <a:p>
-            <a:pPr marL="50799" defTabSz="1219170">
-              <a:lnSpc>
-                <a:spcPts val="2193"/>
-              </a:lnSpc>
-            </a:pPr>
-            <a:fld id="{81D60167-4931-47E6-BA6A-407CBD079E47}" type="slidenum">
-              <a:rPr kern="0" spc="-33" dirty="0"/>
-              <a:pPr marL="50799" defTabSz="1219170">
-                <a:lnSpc>
-                  <a:spcPts val="2193"/>
-                </a:lnSpc>
-              </a:pPr>
-              <a:t>5</a:t>
-            </a:fld>
-            <a:endParaRPr kern="0" spc="-33" dirty="0"/>
-          </a:p>
-        </p:txBody>
-      </p:sp>
-    </p:spTree>
-    <p:custDataLst>
-      <p:tags r:id="rId1"/>
-    </p:custDataLst>
-  </p:cSld>
-  <p:clrMapOvr>
-    <a:masterClrMapping/>
-  </p:clrMapOvr>
-</p:sld>
-</file>
-
-<file path=ppt/slides/slide6.xml><?xml version="1.0" encoding="utf-8"?>
-<p:sld xmlns:a="http://schemas.openxmlformats.org/drawingml/2006/main" xmlns:r="http://schemas.openxmlformats.org/officeDocument/2006/relationships" xmlns:p="http://schemas.openxmlformats.org/presentationml/2006/main" showMasterSp="0">
-  <p:cSld>
-    <p:spTree>
-      <p:nvGrpSpPr>
-        <p:cNvPr id="1" name=""/>
-        <p:cNvGrpSpPr/>
-        <p:nvPr/>
-      </p:nvGrpSpPr>
-      <p:grpSpPr>
-        <a:xfrm>
-          <a:off x="0" y="0"/>
-          <a:ext cx="0" cy="0"/>
-          <a:chOff x="0" y="0"/>
-          <a:chExt cx="0" cy="0"/>
-        </a:xfrm>
-      </p:grpSpPr>
-      <p:sp>
-        <p:nvSpPr>
-          <p:cNvPr id="2" name="object 2"/>
-          <p:cNvSpPr txBox="1"/>
-          <p:nvPr/>
-        </p:nvSpPr>
-        <p:spPr>
-          <a:xfrm>
-            <a:off x="2230487" y="2636519"/>
-            <a:ext cx="3136900" cy="359073"/>
-          </a:xfrm>
-          <a:prstGeom prst="rect">
-            <a:avLst/>
-          </a:prstGeom>
-          <a:solidFill>
-            <a:srgbClr val="FFFF00"/>
-          </a:solidFill>
-        </p:spPr>
-        <p:txBody>
-          <a:bodyPr vert="horz" wrap="square" lIns="0" tIns="0" rIns="0" bIns="0" rtlCol="0">
-            <a:spAutoFit/>
-          </a:bodyPr>
-          <a:lstStyle/>
-          <a:p>
-            <a:pPr defTabSz="1219170">
-              <a:lnSpc>
-                <a:spcPts val="2787"/>
-              </a:lnSpc>
-            </a:pPr>
-            <a:r>
-              <a:rPr sz="2400" kern="0" dirty="0">
-                <a:solidFill>
-                  <a:srgbClr val="434343"/>
-                </a:solidFill>
-                <a:latin typeface="Roboto"/>
-                <a:cs typeface="Roboto"/>
-              </a:rPr>
-              <a:t>FCCID</a:t>
-            </a:r>
-            <a:r>
-              <a:rPr sz="2400" kern="0" spc="-53" dirty="0">
-                <a:solidFill>
-                  <a:srgbClr val="434343"/>
-                </a:solidFill>
-                <a:latin typeface="Roboto"/>
-                <a:cs typeface="Roboto"/>
-              </a:rPr>
-              <a:t> </a:t>
-            </a:r>
-            <a:r>
-              <a:rPr sz="2400" kern="0" dirty="0">
-                <a:solidFill>
-                  <a:srgbClr val="434343"/>
-                </a:solidFill>
-                <a:latin typeface="Roboto"/>
-                <a:cs typeface="Roboto"/>
-              </a:rPr>
-              <a:t>[ID</a:t>
-            </a:r>
-            <a:r>
-              <a:rPr sz="2400" kern="0" spc="-47" dirty="0">
-                <a:solidFill>
-                  <a:srgbClr val="434343"/>
-                </a:solidFill>
-                <a:latin typeface="Roboto"/>
-                <a:cs typeface="Roboto"/>
-              </a:rPr>
-              <a:t> </a:t>
-            </a:r>
-            <a:r>
-              <a:rPr sz="2400" kern="0" dirty="0">
-                <a:solidFill>
-                  <a:srgbClr val="434343"/>
-                </a:solidFill>
-                <a:latin typeface="Roboto"/>
-                <a:cs typeface="Roboto"/>
-              </a:rPr>
-              <a:t>ON</a:t>
-            </a:r>
-            <a:r>
-              <a:rPr sz="2400" kern="0" spc="-47" dirty="0">
-                <a:solidFill>
-                  <a:srgbClr val="434343"/>
-                </a:solidFill>
-                <a:latin typeface="Roboto"/>
-                <a:cs typeface="Roboto"/>
-              </a:rPr>
-              <a:t> </a:t>
-            </a:r>
-            <a:r>
-              <a:rPr sz="2400" kern="0" dirty="0">
-                <a:solidFill>
-                  <a:srgbClr val="434343"/>
-                </a:solidFill>
-                <a:latin typeface="Roboto"/>
-                <a:cs typeface="Roboto"/>
-              </a:rPr>
-              <a:t>KEY</a:t>
-            </a:r>
-            <a:r>
-              <a:rPr sz="2400" kern="0" spc="-47" dirty="0">
-                <a:solidFill>
-                  <a:srgbClr val="434343"/>
-                </a:solidFill>
-                <a:latin typeface="Roboto"/>
-                <a:cs typeface="Roboto"/>
-              </a:rPr>
-              <a:t> </a:t>
-            </a:r>
-            <a:r>
-              <a:rPr sz="2400" kern="0" spc="-27" dirty="0">
-                <a:solidFill>
-                  <a:srgbClr val="434343"/>
-                </a:solidFill>
-                <a:latin typeface="Roboto"/>
-                <a:cs typeface="Roboto"/>
-              </a:rPr>
-              <a:t>FOB]</a:t>
-            </a:r>
-            <a:endParaRPr sz="2400" kern="0">
-              <a:solidFill>
-                <a:sysClr val="windowText" lastClr="000000"/>
-              </a:solidFill>
-              <a:latin typeface="Roboto"/>
-              <a:cs typeface="Roboto"/>
-            </a:endParaRPr>
-          </a:p>
-        </p:txBody>
-      </p:sp>
-      <p:sp>
-        <p:nvSpPr>
-          <p:cNvPr id="3" name="object 3"/>
-          <p:cNvSpPr txBox="1"/>
-          <p:nvPr/>
-        </p:nvSpPr>
-        <p:spPr>
-          <a:xfrm>
-            <a:off x="646095" y="1875874"/>
-            <a:ext cx="6189980" cy="1494426"/>
-          </a:xfrm>
-          <a:prstGeom prst="rect">
-            <a:avLst/>
-          </a:prstGeom>
-        </p:spPr>
-        <p:txBody>
-          <a:bodyPr vert="horz" wrap="square" lIns="0" tIns="16933" rIns="0" bIns="0" rtlCol="0">
-            <a:spAutoFit/>
-          </a:bodyPr>
-          <a:lstStyle/>
-          <a:p>
-            <a:pPr marL="572331" indent="-555398" defTabSz="1219170">
-              <a:spcBef>
-                <a:spcPts val="133"/>
-              </a:spcBef>
-              <a:buFontTx/>
-              <a:buAutoNum type="arabicPeriod"/>
-              <a:tabLst>
-                <a:tab pos="572331" algn="l"/>
-              </a:tabLst>
-            </a:pPr>
-            <a:r>
-              <a:rPr sz="2400" kern="0" spc="-27" dirty="0">
-                <a:solidFill>
-                  <a:srgbClr val="434343"/>
-                </a:solidFill>
-                <a:latin typeface="Roboto"/>
-                <a:cs typeface="Roboto"/>
-              </a:rPr>
-              <a:t>Take</a:t>
-            </a:r>
-            <a:r>
-              <a:rPr sz="2400" kern="0" spc="-47" dirty="0">
-                <a:solidFill>
-                  <a:srgbClr val="434343"/>
-                </a:solidFill>
-                <a:latin typeface="Roboto"/>
-                <a:cs typeface="Roboto"/>
-              </a:rPr>
-              <a:t> </a:t>
-            </a:r>
-            <a:r>
-              <a:rPr sz="2400" kern="0" dirty="0">
-                <a:solidFill>
-                  <a:srgbClr val="434343"/>
-                </a:solidFill>
-                <a:latin typeface="Roboto"/>
-                <a:cs typeface="Roboto"/>
-              </a:rPr>
-              <a:t>a</a:t>
-            </a:r>
-            <a:r>
-              <a:rPr sz="2400" kern="0" spc="-40" dirty="0">
-                <a:solidFill>
-                  <a:srgbClr val="434343"/>
-                </a:solidFill>
-                <a:latin typeface="Roboto"/>
-                <a:cs typeface="Roboto"/>
-              </a:rPr>
-              <a:t> </a:t>
-            </a:r>
-            <a:r>
-              <a:rPr sz="2400" kern="0" dirty="0">
-                <a:solidFill>
-                  <a:srgbClr val="434343"/>
-                </a:solidFill>
-                <a:latin typeface="Roboto"/>
-                <a:cs typeface="Roboto"/>
-              </a:rPr>
-              <a:t>key</a:t>
-            </a:r>
-            <a:r>
-              <a:rPr sz="2400" kern="0" spc="-40" dirty="0">
-                <a:solidFill>
-                  <a:srgbClr val="434343"/>
-                </a:solidFill>
-                <a:latin typeface="Roboto"/>
-                <a:cs typeface="Roboto"/>
-              </a:rPr>
-              <a:t> </a:t>
-            </a:r>
-            <a:r>
-              <a:rPr sz="2400" kern="0" dirty="0">
-                <a:solidFill>
-                  <a:srgbClr val="434343"/>
-                </a:solidFill>
-                <a:latin typeface="Roboto"/>
-                <a:cs typeface="Roboto"/>
-              </a:rPr>
-              <a:t>fob</a:t>
-            </a:r>
-            <a:r>
-              <a:rPr sz="2400" kern="0" spc="-47" dirty="0">
-                <a:solidFill>
-                  <a:srgbClr val="434343"/>
-                </a:solidFill>
-                <a:latin typeface="Roboto"/>
-                <a:cs typeface="Roboto"/>
-              </a:rPr>
-              <a:t> </a:t>
-            </a:r>
-            <a:r>
-              <a:rPr sz="2400" kern="0" dirty="0">
-                <a:solidFill>
-                  <a:srgbClr val="434343"/>
-                </a:solidFill>
-                <a:latin typeface="Roboto"/>
-                <a:cs typeface="Roboto"/>
-              </a:rPr>
-              <a:t>/</a:t>
-            </a:r>
-            <a:r>
-              <a:rPr sz="2400" kern="0" spc="-40" dirty="0">
-                <a:solidFill>
-                  <a:srgbClr val="434343"/>
-                </a:solidFill>
-                <a:latin typeface="Roboto"/>
-                <a:cs typeface="Roboto"/>
-              </a:rPr>
-              <a:t> </a:t>
-            </a:r>
-            <a:r>
-              <a:rPr sz="2400" kern="0" dirty="0">
-                <a:solidFill>
-                  <a:srgbClr val="434343"/>
-                </a:solidFill>
-                <a:latin typeface="Roboto"/>
-                <a:cs typeface="Roboto"/>
-              </a:rPr>
-              <a:t>Use</a:t>
-            </a:r>
-            <a:r>
-              <a:rPr sz="2400" kern="0" spc="-40" dirty="0">
-                <a:solidFill>
-                  <a:srgbClr val="434343"/>
-                </a:solidFill>
-                <a:latin typeface="Roboto"/>
-                <a:cs typeface="Roboto"/>
-              </a:rPr>
-              <a:t> </a:t>
-            </a:r>
-            <a:r>
-              <a:rPr sz="2400" kern="0" dirty="0">
-                <a:solidFill>
-                  <a:srgbClr val="434343"/>
-                </a:solidFill>
-                <a:latin typeface="Roboto"/>
-                <a:cs typeface="Roboto"/>
-              </a:rPr>
-              <a:t>your</a:t>
-            </a:r>
-            <a:r>
-              <a:rPr sz="2400" kern="0" spc="-47" dirty="0">
-                <a:solidFill>
-                  <a:srgbClr val="434343"/>
-                </a:solidFill>
-                <a:latin typeface="Roboto"/>
-                <a:cs typeface="Roboto"/>
-              </a:rPr>
-              <a:t> </a:t>
-            </a:r>
-            <a:r>
-              <a:rPr sz="2400" kern="0" dirty="0">
-                <a:solidFill>
-                  <a:srgbClr val="434343"/>
-                </a:solidFill>
-                <a:latin typeface="Roboto"/>
-                <a:cs typeface="Roboto"/>
-              </a:rPr>
-              <a:t>own</a:t>
-            </a:r>
-            <a:r>
-              <a:rPr sz="2400" kern="0" spc="-40" dirty="0">
-                <a:solidFill>
-                  <a:srgbClr val="434343"/>
-                </a:solidFill>
-                <a:latin typeface="Roboto"/>
-                <a:cs typeface="Roboto"/>
-              </a:rPr>
-              <a:t> </a:t>
-            </a:r>
-            <a:r>
-              <a:rPr sz="2400" kern="0" dirty="0">
-                <a:solidFill>
-                  <a:srgbClr val="434343"/>
-                </a:solidFill>
-                <a:latin typeface="Roboto"/>
-                <a:cs typeface="Roboto"/>
-              </a:rPr>
-              <a:t>key</a:t>
-            </a:r>
-            <a:r>
-              <a:rPr sz="2400" kern="0" spc="-40" dirty="0">
-                <a:solidFill>
-                  <a:srgbClr val="434343"/>
-                </a:solidFill>
-                <a:latin typeface="Roboto"/>
-                <a:cs typeface="Roboto"/>
-              </a:rPr>
-              <a:t> </a:t>
-            </a:r>
-            <a:r>
-              <a:rPr sz="2400" kern="0" spc="-33" dirty="0">
-                <a:solidFill>
-                  <a:srgbClr val="434343"/>
-                </a:solidFill>
-                <a:latin typeface="Roboto"/>
-                <a:cs typeface="Roboto"/>
-              </a:rPr>
-              <a:t>fob</a:t>
-            </a:r>
-            <a:endParaRPr sz="2400" kern="0" dirty="0">
-              <a:solidFill>
-                <a:sysClr val="windowText" lastClr="000000"/>
-              </a:solidFill>
-              <a:latin typeface="Roboto"/>
-              <a:cs typeface="Roboto"/>
-            </a:endParaRPr>
-          </a:p>
-          <a:p>
-            <a:pPr marL="572331" indent="-555398" defTabSz="1219170">
-              <a:buFontTx/>
-              <a:buAutoNum type="arabicPeriod"/>
-              <a:tabLst>
-                <a:tab pos="572331" algn="l"/>
-              </a:tabLst>
-            </a:pPr>
-            <a:r>
-              <a:rPr sz="2400" kern="0" dirty="0">
-                <a:solidFill>
-                  <a:srgbClr val="434343"/>
-                </a:solidFill>
-                <a:latin typeface="Roboto"/>
-                <a:cs typeface="Roboto"/>
-              </a:rPr>
-              <a:t>Find</a:t>
-            </a:r>
-            <a:r>
-              <a:rPr sz="2400" kern="0" spc="-47" dirty="0">
-                <a:solidFill>
-                  <a:srgbClr val="434343"/>
-                </a:solidFill>
-                <a:latin typeface="Roboto"/>
-                <a:cs typeface="Roboto"/>
-              </a:rPr>
-              <a:t> </a:t>
-            </a:r>
-            <a:r>
-              <a:rPr sz="2400" kern="0" dirty="0">
-                <a:solidFill>
-                  <a:srgbClr val="434343"/>
-                </a:solidFill>
-                <a:latin typeface="Roboto"/>
-                <a:cs typeface="Roboto"/>
-              </a:rPr>
-              <a:t>the</a:t>
-            </a:r>
-            <a:r>
-              <a:rPr sz="2400" kern="0" spc="-40" dirty="0">
-                <a:solidFill>
-                  <a:srgbClr val="434343"/>
-                </a:solidFill>
-                <a:latin typeface="Roboto"/>
-                <a:cs typeface="Roboto"/>
-              </a:rPr>
-              <a:t> </a:t>
-            </a:r>
-            <a:r>
-              <a:rPr sz="2400" kern="0" dirty="0">
-                <a:solidFill>
-                  <a:srgbClr val="434343"/>
-                </a:solidFill>
-                <a:latin typeface="Roboto"/>
-                <a:cs typeface="Roboto"/>
-              </a:rPr>
-              <a:t>FCCID</a:t>
-            </a:r>
-            <a:r>
-              <a:rPr sz="2400" kern="0" spc="-40" dirty="0">
-                <a:solidFill>
-                  <a:srgbClr val="434343"/>
-                </a:solidFill>
-                <a:latin typeface="Roboto"/>
-                <a:cs typeface="Roboto"/>
-              </a:rPr>
-              <a:t> </a:t>
-            </a:r>
-            <a:r>
-              <a:rPr sz="2400" kern="0" dirty="0">
-                <a:solidFill>
-                  <a:srgbClr val="434343"/>
-                </a:solidFill>
-                <a:latin typeface="Roboto"/>
-                <a:cs typeface="Roboto"/>
-              </a:rPr>
-              <a:t>on</a:t>
-            </a:r>
-            <a:r>
-              <a:rPr sz="2400" kern="0" spc="-40" dirty="0">
-                <a:solidFill>
-                  <a:srgbClr val="434343"/>
-                </a:solidFill>
-                <a:latin typeface="Roboto"/>
-                <a:cs typeface="Roboto"/>
-              </a:rPr>
-              <a:t> </a:t>
-            </a:r>
-            <a:r>
-              <a:rPr sz="2400" kern="0" dirty="0">
-                <a:solidFill>
-                  <a:srgbClr val="434343"/>
-                </a:solidFill>
-                <a:latin typeface="Roboto"/>
-                <a:cs typeface="Roboto"/>
-              </a:rPr>
-              <a:t>the</a:t>
-            </a:r>
-            <a:r>
-              <a:rPr sz="2400" kern="0" spc="-40" dirty="0">
-                <a:solidFill>
-                  <a:srgbClr val="434343"/>
-                </a:solidFill>
-                <a:latin typeface="Roboto"/>
-                <a:cs typeface="Roboto"/>
-              </a:rPr>
-              <a:t> </a:t>
-            </a:r>
-            <a:r>
-              <a:rPr sz="2400" kern="0" dirty="0">
-                <a:solidFill>
-                  <a:srgbClr val="434343"/>
-                </a:solidFill>
-                <a:latin typeface="Roboto"/>
-                <a:cs typeface="Roboto"/>
-              </a:rPr>
-              <a:t>key</a:t>
-            </a:r>
-            <a:r>
-              <a:rPr sz="2400" kern="0" spc="-40" dirty="0">
-                <a:solidFill>
-                  <a:srgbClr val="434343"/>
-                </a:solidFill>
-                <a:latin typeface="Roboto"/>
-                <a:cs typeface="Roboto"/>
-              </a:rPr>
-              <a:t> </a:t>
-            </a:r>
-            <a:r>
-              <a:rPr sz="2400" kern="0" spc="-33" dirty="0">
-                <a:solidFill>
-                  <a:srgbClr val="434343"/>
-                </a:solidFill>
-                <a:latin typeface="Roboto"/>
-                <a:cs typeface="Roboto"/>
-              </a:rPr>
-              <a:t>fob</a:t>
-            </a:r>
-            <a:endParaRPr sz="2400" kern="0" dirty="0">
-              <a:solidFill>
-                <a:sysClr val="windowText" lastClr="000000"/>
-              </a:solidFill>
-              <a:latin typeface="Roboto"/>
-              <a:cs typeface="Roboto"/>
-            </a:endParaRPr>
-          </a:p>
-          <a:p>
-            <a:pPr marL="572331" indent="-555398" defTabSz="1219170">
-              <a:buFontTx/>
-              <a:buAutoNum type="arabicPeriod"/>
-              <a:tabLst>
-                <a:tab pos="572331" algn="l"/>
-                <a:tab pos="4795400" algn="l"/>
-              </a:tabLst>
-            </a:pPr>
-            <a:r>
-              <a:rPr sz="2400" kern="0" spc="-13" dirty="0">
-                <a:solidFill>
-                  <a:srgbClr val="434343"/>
-                </a:solidFill>
-                <a:latin typeface="Roboto"/>
-                <a:cs typeface="Roboto"/>
-              </a:rPr>
-              <a:t>Search</a:t>
-            </a:r>
-            <a:r>
-              <a:rPr lang="en-US" sz="2400" kern="0" dirty="0">
-                <a:solidFill>
-                  <a:srgbClr val="434343"/>
-                </a:solidFill>
-                <a:latin typeface="Roboto"/>
-                <a:cs typeface="Roboto"/>
-              </a:rPr>
-              <a:t>	</a:t>
-            </a:r>
-            <a:r>
-              <a:rPr sz="2400" kern="0" dirty="0">
-                <a:solidFill>
-                  <a:srgbClr val="434343"/>
-                </a:solidFill>
-                <a:latin typeface="Roboto"/>
-                <a:cs typeface="Roboto"/>
-              </a:rPr>
-              <a:t>on</a:t>
-            </a:r>
-            <a:r>
-              <a:rPr sz="2400" kern="0" spc="-27" dirty="0">
-                <a:solidFill>
-                  <a:srgbClr val="434343"/>
-                </a:solidFill>
-                <a:latin typeface="Roboto"/>
-                <a:cs typeface="Roboto"/>
-              </a:rPr>
-              <a:t> </a:t>
-            </a:r>
-            <a:r>
-              <a:rPr sz="2400" kern="0" spc="-13" dirty="0">
-                <a:solidFill>
-                  <a:srgbClr val="434343"/>
-                </a:solidFill>
-                <a:latin typeface="Roboto"/>
-                <a:cs typeface="Roboto"/>
-              </a:rPr>
-              <a:t>Google</a:t>
-            </a:r>
-            <a:endParaRPr lang="en-US" sz="2400" kern="0" spc="-13" dirty="0">
-              <a:solidFill>
-                <a:srgbClr val="434343"/>
-              </a:solidFill>
-              <a:latin typeface="Roboto"/>
-              <a:cs typeface="Roboto"/>
-            </a:endParaRPr>
-          </a:p>
-          <a:p>
-            <a:pPr marL="572331" indent="-555398" defTabSz="1219170">
-              <a:buFontTx/>
-              <a:buAutoNum type="arabicPeriod"/>
-              <a:tabLst>
-                <a:tab pos="572331" algn="l"/>
-                <a:tab pos="4795400" algn="l"/>
-              </a:tabLst>
-            </a:pPr>
-            <a:r>
-              <a:rPr lang="en-US" sz="2400" kern="0" dirty="0">
-                <a:solidFill>
-                  <a:sysClr val="windowText" lastClr="000000"/>
-                </a:solidFill>
-                <a:latin typeface="Roboto"/>
-                <a:cs typeface="Roboto"/>
-              </a:rPr>
-              <a:t>https://www.fcc.gov/oet/ea/fccid</a:t>
-            </a:r>
-            <a:endParaRPr sz="2400" kern="0" dirty="0">
-              <a:solidFill>
-                <a:sysClr val="windowText" lastClr="000000"/>
-              </a:solidFill>
-              <a:latin typeface="Roboto"/>
-              <a:cs typeface="Roboto"/>
-            </a:endParaRPr>
-          </a:p>
-        </p:txBody>
-      </p:sp>
-      <p:sp>
-        <p:nvSpPr>
-          <p:cNvPr id="4" name="object 4"/>
-          <p:cNvSpPr txBox="1"/>
-          <p:nvPr/>
-        </p:nvSpPr>
-        <p:spPr>
-          <a:xfrm>
-            <a:off x="604886" y="3743960"/>
-            <a:ext cx="6833447" cy="427532"/>
-          </a:xfrm>
-          <a:prstGeom prst="rect">
-            <a:avLst/>
-          </a:prstGeom>
-        </p:spPr>
-        <p:txBody>
-          <a:bodyPr vert="horz" wrap="square" lIns="0" tIns="16933" rIns="0" bIns="0" rtlCol="0">
-            <a:spAutoFit/>
-          </a:bodyPr>
-          <a:lstStyle/>
-          <a:p>
-            <a:pPr marL="16933" defTabSz="1219170">
-              <a:spcBef>
-                <a:spcPts val="133"/>
-              </a:spcBef>
-              <a:tabLst>
-                <a:tab pos="613818" algn="l"/>
-              </a:tabLst>
-            </a:pPr>
-            <a:r>
-              <a:rPr sz="2667" b="1" kern="0" spc="-33" dirty="0">
-                <a:solidFill>
-                  <a:srgbClr val="D13368"/>
-                </a:solidFill>
-                <a:latin typeface="Roboto"/>
-                <a:cs typeface="Roboto"/>
-              </a:rPr>
-              <a:t>4.</a:t>
-            </a:r>
-            <a:r>
-              <a:rPr sz="2667" b="1" kern="0" dirty="0">
-                <a:solidFill>
-                  <a:srgbClr val="D13368"/>
-                </a:solidFill>
-                <a:latin typeface="Roboto"/>
-                <a:cs typeface="Roboto"/>
-              </a:rPr>
-              <a:t>	What</a:t>
-            </a:r>
-            <a:r>
-              <a:rPr sz="2667" b="1" kern="0" spc="-53" dirty="0">
-                <a:solidFill>
-                  <a:srgbClr val="D13368"/>
-                </a:solidFill>
-                <a:latin typeface="Roboto"/>
-                <a:cs typeface="Roboto"/>
-              </a:rPr>
-              <a:t> </a:t>
-            </a:r>
-            <a:r>
-              <a:rPr sz="2667" b="1" kern="0" dirty="0">
-                <a:solidFill>
-                  <a:srgbClr val="D13368"/>
-                </a:solidFill>
-                <a:latin typeface="Roboto"/>
-                <a:cs typeface="Roboto"/>
-              </a:rPr>
-              <a:t>frequency</a:t>
-            </a:r>
-            <a:r>
-              <a:rPr sz="2667" b="1" kern="0" spc="-47" dirty="0">
-                <a:solidFill>
-                  <a:srgbClr val="D13368"/>
-                </a:solidFill>
-                <a:latin typeface="Roboto"/>
-                <a:cs typeface="Roboto"/>
-              </a:rPr>
-              <a:t> </a:t>
-            </a:r>
-            <a:r>
-              <a:rPr sz="2667" b="1" kern="0" dirty="0">
-                <a:solidFill>
-                  <a:srgbClr val="D13368"/>
-                </a:solidFill>
-                <a:latin typeface="Roboto"/>
-                <a:cs typeface="Roboto"/>
-              </a:rPr>
-              <a:t>does</a:t>
-            </a:r>
-            <a:r>
-              <a:rPr sz="2667" b="1" kern="0" spc="-53" dirty="0">
-                <a:solidFill>
-                  <a:srgbClr val="D13368"/>
-                </a:solidFill>
-                <a:latin typeface="Roboto"/>
-                <a:cs typeface="Roboto"/>
-              </a:rPr>
-              <a:t> </a:t>
-            </a:r>
-            <a:r>
-              <a:rPr sz="2667" b="1" kern="0" dirty="0">
-                <a:solidFill>
-                  <a:srgbClr val="D13368"/>
-                </a:solidFill>
-                <a:latin typeface="Roboto"/>
-                <a:cs typeface="Roboto"/>
-              </a:rPr>
-              <a:t>the</a:t>
-            </a:r>
-            <a:r>
-              <a:rPr sz="2667" b="1" kern="0" spc="-47" dirty="0">
-                <a:solidFill>
-                  <a:srgbClr val="D13368"/>
-                </a:solidFill>
-                <a:latin typeface="Roboto"/>
-                <a:cs typeface="Roboto"/>
-              </a:rPr>
-              <a:t> </a:t>
-            </a:r>
-            <a:r>
-              <a:rPr sz="2667" b="1" kern="0" dirty="0">
-                <a:solidFill>
-                  <a:srgbClr val="D13368"/>
-                </a:solidFill>
-                <a:latin typeface="Roboto"/>
-                <a:cs typeface="Roboto"/>
-              </a:rPr>
-              <a:t>key</a:t>
-            </a:r>
-            <a:r>
-              <a:rPr sz="2667" b="1" kern="0" spc="-53" dirty="0">
-                <a:solidFill>
-                  <a:srgbClr val="D13368"/>
-                </a:solidFill>
-                <a:latin typeface="Roboto"/>
-                <a:cs typeface="Roboto"/>
-              </a:rPr>
-              <a:t> </a:t>
-            </a:r>
-            <a:r>
-              <a:rPr sz="2667" b="1" kern="0" dirty="0">
-                <a:solidFill>
-                  <a:srgbClr val="D13368"/>
-                </a:solidFill>
-                <a:latin typeface="Roboto"/>
-                <a:cs typeface="Roboto"/>
-              </a:rPr>
-              <a:t>fob</a:t>
-            </a:r>
-            <a:r>
-              <a:rPr sz="2667" b="1" kern="0" spc="-47" dirty="0">
-                <a:solidFill>
-                  <a:srgbClr val="D13368"/>
-                </a:solidFill>
-                <a:latin typeface="Roboto"/>
-                <a:cs typeface="Roboto"/>
-              </a:rPr>
-              <a:t> </a:t>
-            </a:r>
-            <a:r>
-              <a:rPr sz="2667" b="1" kern="0" dirty="0">
-                <a:solidFill>
-                  <a:srgbClr val="D13368"/>
-                </a:solidFill>
-                <a:latin typeface="Roboto"/>
-                <a:cs typeface="Roboto"/>
-              </a:rPr>
-              <a:t>run</a:t>
-            </a:r>
-            <a:r>
-              <a:rPr sz="2667" b="1" kern="0" spc="-53" dirty="0">
-                <a:solidFill>
-                  <a:srgbClr val="D13368"/>
-                </a:solidFill>
-                <a:latin typeface="Roboto"/>
-                <a:cs typeface="Roboto"/>
-              </a:rPr>
-              <a:t> </a:t>
-            </a:r>
-            <a:r>
-              <a:rPr sz="2667" b="1" kern="0" spc="-33" dirty="0">
-                <a:solidFill>
-                  <a:srgbClr val="D13368"/>
-                </a:solidFill>
-                <a:latin typeface="Roboto"/>
-                <a:cs typeface="Roboto"/>
-              </a:rPr>
-              <a:t>on?</a:t>
-            </a:r>
-            <a:endParaRPr sz="2667" kern="0">
-              <a:solidFill>
-                <a:sysClr val="windowText" lastClr="000000"/>
-              </a:solidFill>
-              <a:latin typeface="Roboto"/>
-              <a:cs typeface="Roboto"/>
-            </a:endParaRPr>
-          </a:p>
-        </p:txBody>
-      </p:sp>
-      <p:sp>
-        <p:nvSpPr>
-          <p:cNvPr id="7" name="object 7"/>
-          <p:cNvSpPr txBox="1">
-            <a:spLocks noGrp="1"/>
-          </p:cNvSpPr>
-          <p:nvPr>
-            <p:ph type="sldNum" sz="quarter" idx="12"/>
-          </p:nvPr>
-        </p:nvSpPr>
-        <p:spPr>
-          <a:prstGeom prst="rect">
-            <a:avLst/>
-          </a:prstGeom>
-        </p:spPr>
-        <p:txBody>
-          <a:bodyPr vert="horz" wrap="square" lIns="0" tIns="0" rIns="0" bIns="0" rtlCol="0">
-            <a:spAutoFit/>
-          </a:bodyPr>
-          <a:lstStyle/>
-          <a:p>
-            <a:pPr marL="50799" defTabSz="1219170">
-              <a:lnSpc>
-                <a:spcPts val="2193"/>
-              </a:lnSpc>
-            </a:pPr>
-            <a:fld id="{81D60167-4931-47E6-BA6A-407CBD079E47}" type="slidenum">
-              <a:rPr kern="0" spc="-33" dirty="0"/>
-              <a:pPr marL="50799" defTabSz="1219170">
-                <a:lnSpc>
-                  <a:spcPts val="2193"/>
-                </a:lnSpc>
-              </a:pPr>
-              <a:t>6</a:t>
-            </a:fld>
-            <a:endParaRPr kern="0" spc="-33" dirty="0"/>
-          </a:p>
-        </p:txBody>
-      </p:sp>
-      <p:sp>
-        <p:nvSpPr>
-          <p:cNvPr id="5" name="object 5" descr="$PPTXTitle"/>
-          <p:cNvSpPr txBox="1">
-            <a:spLocks noGrp="1"/>
-          </p:cNvSpPr>
-          <p:nvPr>
-            <p:ph type="title" idx="4294967295"/>
-          </p:nvPr>
-        </p:nvSpPr>
-        <p:spPr>
-          <a:xfrm>
-            <a:off x="0" y="557213"/>
-            <a:ext cx="6330950" cy="631825"/>
-          </a:xfrm>
-          <a:prstGeom prst="rect">
-            <a:avLst/>
-          </a:prstGeom>
-        </p:spPr>
-        <p:txBody>
-          <a:bodyPr vert="horz" wrap="square" lIns="0" tIns="16933" rIns="0" bIns="0" rtlCol="0">
-            <a:spAutoFit/>
-          </a:bodyPr>
-          <a:lstStyle/>
-          <a:p>
-            <a:pPr marL="16933">
-              <a:spcBef>
-                <a:spcPts val="133"/>
-              </a:spcBef>
-            </a:pPr>
-            <a:r>
-              <a:rPr dirty="0"/>
-              <a:t>FCCID</a:t>
-            </a:r>
-            <a:r>
-              <a:rPr spc="-80" dirty="0"/>
-              <a:t> </a:t>
-            </a:r>
-            <a:r>
-              <a:rPr dirty="0"/>
-              <a:t>Lookup</a:t>
-            </a:r>
-            <a:r>
-              <a:rPr spc="-60" dirty="0"/>
-              <a:t> </a:t>
-            </a:r>
-            <a:r>
-              <a:rPr dirty="0">
-                <a:solidFill>
-                  <a:srgbClr val="2A3890"/>
-                </a:solidFill>
-              </a:rPr>
-              <a:t>–</a:t>
-            </a:r>
-            <a:r>
-              <a:rPr spc="-80" dirty="0">
-                <a:solidFill>
-                  <a:srgbClr val="2A3890"/>
-                </a:solidFill>
-              </a:rPr>
-              <a:t> </a:t>
-            </a:r>
-            <a:r>
-              <a:rPr spc="-13" dirty="0">
-                <a:solidFill>
-                  <a:srgbClr val="2A3890"/>
-                </a:solidFill>
-              </a:rPr>
-              <a:t>Exercise</a:t>
-            </a:r>
-          </a:p>
-        </p:txBody>
-      </p:sp>
-      <p:pic>
-        <p:nvPicPr>
-          <p:cNvPr id="6" name="object 6"/>
-          <p:cNvPicPr/>
-          <p:nvPr/>
-        </p:nvPicPr>
-        <p:blipFill>
-          <a:blip r:embed="rId3" cstate="email">
-            <a:extLst>
-              <a:ext uri="{28A0092B-C50C-407E-A947-70E740481C1C}">
-                <a14:useLocalDpi xmlns:a14="http://schemas.microsoft.com/office/drawing/2010/main"/>
-              </a:ext>
-            </a:extLst>
-          </a:blip>
-          <a:stretch>
-            <a:fillRect/>
-          </a:stretch>
-        </p:blipFill>
-        <p:spPr>
-          <a:xfrm>
-            <a:off x="8112132" y="814367"/>
-            <a:ext cx="3368832" cy="5692767"/>
-          </a:xfrm>
-          <a:prstGeom prst="rect">
-            <a:avLst/>
-          </a:prstGeom>
-        </p:spPr>
-      </p:pic>
-    </p:spTree>
-    <p:custDataLst>
-      <p:tags r:id="rId1"/>
-    </p:custDataLst>
-  </p:cSld>
-  <p:clrMapOvr>
-    <a:masterClrMapping/>
-  </p:clrMapOvr>
-</p:sld>
-</file>
-
-<file path=ppt/slides/slide7.xml><?xml version="1.0" encoding="utf-8"?>
-<p:sld xmlns:a="http://schemas.openxmlformats.org/drawingml/2006/main" xmlns:r="http://schemas.openxmlformats.org/officeDocument/2006/relationships" xmlns:p="http://schemas.openxmlformats.org/presentationml/2006/main" showMasterSp="0">
-  <p:cSld>
-    <p:spTree>
-      <p:nvGrpSpPr>
-        <p:cNvPr id="1" name=""/>
-        <p:cNvGrpSpPr/>
-        <p:nvPr/>
-      </p:nvGrpSpPr>
-      <p:grpSpPr>
-        <a:xfrm>
-          <a:off x="0" y="0"/>
-          <a:ext cx="0" cy="0"/>
-          <a:chOff x="0" y="0"/>
-          <a:chExt cx="0" cy="0"/>
-        </a:xfrm>
-      </p:grpSpPr>
-      <p:sp>
-        <p:nvSpPr>
-          <p:cNvPr id="2" name="object 2" descr="$PPTXTitle"/>
-          <p:cNvSpPr txBox="1">
-            <a:spLocks noGrp="1"/>
-          </p:cNvSpPr>
-          <p:nvPr>
-            <p:ph type="title" idx="4294967295"/>
-          </p:nvPr>
-        </p:nvSpPr>
-        <p:spPr>
-          <a:xfrm>
-            <a:off x="0" y="613363"/>
-            <a:ext cx="8370771" cy="631825"/>
-          </a:xfrm>
-          <a:prstGeom prst="rect">
-            <a:avLst/>
-          </a:prstGeom>
-        </p:spPr>
-        <p:txBody>
-          <a:bodyPr vert="horz" wrap="square" lIns="0" tIns="16933" rIns="0" bIns="0" rtlCol="0">
-            <a:spAutoFit/>
-          </a:bodyPr>
-          <a:lstStyle/>
-          <a:p>
-            <a:pPr marL="16933">
-              <a:spcBef>
-                <a:spcPts val="133"/>
-              </a:spcBef>
-            </a:pPr>
-            <a:r>
-              <a:rPr dirty="0"/>
-              <a:t>FCCID</a:t>
-            </a:r>
-            <a:r>
-              <a:rPr spc="-73" dirty="0"/>
-              <a:t> </a:t>
-            </a:r>
-            <a:r>
-              <a:rPr dirty="0"/>
-              <a:t>Lookup</a:t>
-            </a:r>
-            <a:r>
-              <a:rPr spc="-47" dirty="0"/>
-              <a:t> </a:t>
-            </a:r>
-            <a:r>
-              <a:rPr dirty="0">
-                <a:solidFill>
-                  <a:srgbClr val="2A3890"/>
-                </a:solidFill>
-              </a:rPr>
-              <a:t>–</a:t>
-            </a:r>
-            <a:r>
-              <a:rPr spc="-67" dirty="0">
-                <a:solidFill>
-                  <a:srgbClr val="2A3890"/>
-                </a:solidFill>
-              </a:rPr>
-              <a:t> </a:t>
-            </a:r>
-            <a:r>
-              <a:rPr dirty="0">
-                <a:solidFill>
-                  <a:srgbClr val="2A3890"/>
-                </a:solidFill>
-              </a:rPr>
-              <a:t>Other</a:t>
-            </a:r>
-            <a:r>
-              <a:rPr spc="-67" dirty="0">
-                <a:solidFill>
-                  <a:srgbClr val="2A3890"/>
-                </a:solidFill>
-              </a:rPr>
-              <a:t> </a:t>
-            </a:r>
-            <a:r>
-              <a:rPr spc="-13" dirty="0">
-                <a:solidFill>
-                  <a:srgbClr val="2A3890"/>
-                </a:solidFill>
-              </a:rPr>
-              <a:t>Examples</a:t>
-            </a:r>
-          </a:p>
-        </p:txBody>
-      </p:sp>
-      <p:grpSp>
-        <p:nvGrpSpPr>
-          <p:cNvPr id="3" name="object 3"/>
-          <p:cNvGrpSpPr/>
-          <p:nvPr/>
-        </p:nvGrpSpPr>
-        <p:grpSpPr>
-          <a:xfrm>
-            <a:off x="1341934" y="1509400"/>
-            <a:ext cx="3553460" cy="2198793"/>
-            <a:chOff x="1006450" y="1132049"/>
-            <a:chExt cx="2665095" cy="1649095"/>
-          </a:xfrm>
-        </p:grpSpPr>
-        <p:pic>
-          <p:nvPicPr>
-            <p:cNvPr id="4" name="object 4"/>
-            <p:cNvPicPr/>
-            <p:nvPr/>
-          </p:nvPicPr>
-          <p:blipFill>
-            <a:blip r:embed="rId3" cstate="email">
-              <a:extLst>
-                <a:ext uri="{28A0092B-C50C-407E-A947-70E740481C1C}">
-                  <a14:useLocalDpi xmlns:a14="http://schemas.microsoft.com/office/drawing/2010/main"/>
-                </a:ext>
-              </a:extLst>
-            </a:blip>
-            <a:stretch>
-              <a:fillRect/>
-            </a:stretch>
-          </p:blipFill>
-          <p:spPr>
-            <a:xfrm>
-              <a:off x="1015975" y="1141574"/>
-              <a:ext cx="2645450" cy="1629425"/>
-            </a:xfrm>
-            <a:prstGeom prst="rect">
-              <a:avLst/>
-            </a:prstGeom>
-          </p:spPr>
-        </p:pic>
-        <p:sp>
-          <p:nvSpPr>
-            <p:cNvPr id="5" name="object 5"/>
-            <p:cNvSpPr/>
-            <p:nvPr/>
-          </p:nvSpPr>
-          <p:spPr>
-            <a:xfrm>
-              <a:off x="1011212" y="1136812"/>
-              <a:ext cx="2655570" cy="1639570"/>
-            </a:xfrm>
-            <a:custGeom>
-              <a:avLst/>
-              <a:gdLst/>
-              <a:ahLst/>
-              <a:cxnLst/>
-              <a:rect l="l" t="t" r="r" b="b"/>
-              <a:pathLst>
-                <a:path w="2655570" h="1639570">
-                  <a:moveTo>
-                    <a:pt x="0" y="0"/>
-                  </a:moveTo>
-                  <a:lnTo>
-                    <a:pt x="2654975" y="0"/>
-                  </a:lnTo>
-                  <a:lnTo>
-                    <a:pt x="2654975" y="1638950"/>
-                  </a:lnTo>
-                  <a:lnTo>
-                    <a:pt x="0" y="1638950"/>
-                  </a:lnTo>
-                  <a:lnTo>
-                    <a:pt x="0" y="0"/>
-                  </a:lnTo>
-                  <a:close/>
-                </a:path>
-              </a:pathLst>
-            </a:custGeom>
-            <a:ln w="9524">
-              <a:solidFill>
-                <a:srgbClr val="434343"/>
-              </a:solidFill>
-            </a:ln>
-          </p:spPr>
-          <p:txBody>
-            <a:bodyPr wrap="square" lIns="0" tIns="0" rIns="0" bIns="0" rtlCol="0"/>
-            <a:lstStyle/>
-            <a:p>
-              <a:pPr defTabSz="1219170"/>
-              <a:endParaRPr sz="2400" kern="0">
-                <a:solidFill>
-                  <a:sysClr val="windowText" lastClr="000000"/>
-                </a:solidFill>
-              </a:endParaRPr>
-            </a:p>
-          </p:txBody>
-        </p:sp>
-      </p:grpSp>
-      <p:sp>
-        <p:nvSpPr>
-          <p:cNvPr id="6" name="object 6"/>
-          <p:cNvSpPr txBox="1"/>
-          <p:nvPr/>
-        </p:nvSpPr>
-        <p:spPr>
-          <a:xfrm>
-            <a:off x="2159102" y="3779841"/>
-            <a:ext cx="1916007" cy="386430"/>
-          </a:xfrm>
-          <a:prstGeom prst="rect">
-            <a:avLst/>
-          </a:prstGeom>
-        </p:spPr>
-        <p:txBody>
-          <a:bodyPr vert="horz" wrap="square" lIns="0" tIns="16933" rIns="0" bIns="0" rtlCol="0">
-            <a:spAutoFit/>
-          </a:bodyPr>
-          <a:lstStyle/>
-          <a:p>
-            <a:pPr marL="16933" defTabSz="1219170">
-              <a:spcBef>
-                <a:spcPts val="133"/>
-              </a:spcBef>
-            </a:pPr>
-            <a:r>
-              <a:rPr sz="2400" b="1" kern="0" dirty="0">
-                <a:solidFill>
-                  <a:srgbClr val="212D73"/>
-                </a:solidFill>
-                <a:latin typeface="Roboto"/>
-                <a:cs typeface="Roboto"/>
-              </a:rPr>
-              <a:t>iPhone</a:t>
-            </a:r>
-            <a:r>
-              <a:rPr sz="2400" b="1" kern="0" spc="-120" dirty="0">
-                <a:solidFill>
-                  <a:srgbClr val="212D73"/>
-                </a:solidFill>
-                <a:latin typeface="Roboto"/>
-                <a:cs typeface="Roboto"/>
-              </a:rPr>
-              <a:t> </a:t>
-            </a:r>
-            <a:r>
-              <a:rPr sz="2400" b="1" kern="0" spc="-13" dirty="0">
-                <a:solidFill>
-                  <a:srgbClr val="212D73"/>
-                </a:solidFill>
-                <a:latin typeface="Roboto"/>
-                <a:cs typeface="Roboto"/>
-              </a:rPr>
-              <a:t>FCCID</a:t>
-            </a:r>
-            <a:endParaRPr sz="2400" kern="0">
-              <a:solidFill>
-                <a:sysClr val="windowText" lastClr="000000"/>
-              </a:solidFill>
-              <a:latin typeface="Roboto"/>
-              <a:cs typeface="Roboto"/>
-            </a:endParaRPr>
-          </a:p>
-        </p:txBody>
-      </p:sp>
-      <p:grpSp>
-        <p:nvGrpSpPr>
-          <p:cNvPr id="7" name="object 7"/>
-          <p:cNvGrpSpPr/>
-          <p:nvPr/>
-        </p:nvGrpSpPr>
-        <p:grpSpPr>
-          <a:xfrm>
-            <a:off x="7028999" y="1509401"/>
-            <a:ext cx="4030133" cy="2198793"/>
-            <a:chOff x="5271749" y="1132050"/>
-            <a:chExt cx="3022600" cy="1649095"/>
-          </a:xfrm>
-        </p:grpSpPr>
-        <p:pic>
-          <p:nvPicPr>
-            <p:cNvPr id="8" name="object 8"/>
-            <p:cNvPicPr/>
-            <p:nvPr/>
-          </p:nvPicPr>
-          <p:blipFill>
-            <a:blip r:embed="rId4" cstate="email">
-              <a:extLst>
-                <a:ext uri="{28A0092B-C50C-407E-A947-70E740481C1C}">
-                  <a14:useLocalDpi xmlns:a14="http://schemas.microsoft.com/office/drawing/2010/main"/>
-                </a:ext>
-              </a:extLst>
-            </a:blip>
-            <a:stretch>
-              <a:fillRect/>
-            </a:stretch>
-          </p:blipFill>
-          <p:spPr>
-            <a:xfrm>
-              <a:off x="5281274" y="1141575"/>
-              <a:ext cx="3003418" cy="1629424"/>
-            </a:xfrm>
-            <a:prstGeom prst="rect">
-              <a:avLst/>
-            </a:prstGeom>
-          </p:spPr>
-        </p:pic>
-        <p:sp>
-          <p:nvSpPr>
-            <p:cNvPr id="9" name="object 9"/>
-            <p:cNvSpPr/>
-            <p:nvPr/>
-          </p:nvSpPr>
-          <p:spPr>
-            <a:xfrm>
-              <a:off x="5276512" y="1136812"/>
-              <a:ext cx="3013075" cy="1639570"/>
-            </a:xfrm>
-            <a:custGeom>
-              <a:avLst/>
-              <a:gdLst/>
-              <a:ahLst/>
-              <a:cxnLst/>
-              <a:rect l="l" t="t" r="r" b="b"/>
-              <a:pathLst>
-                <a:path w="3013075" h="1639570">
-                  <a:moveTo>
-                    <a:pt x="0" y="0"/>
-                  </a:moveTo>
-                  <a:lnTo>
-                    <a:pt x="3012943" y="0"/>
-                  </a:lnTo>
-                  <a:lnTo>
-                    <a:pt x="3012943" y="1638949"/>
-                  </a:lnTo>
-                  <a:lnTo>
-                    <a:pt x="0" y="1638949"/>
-                  </a:lnTo>
-                  <a:lnTo>
-                    <a:pt x="0" y="0"/>
-                  </a:lnTo>
-                  <a:close/>
-                </a:path>
-              </a:pathLst>
-            </a:custGeom>
-            <a:ln w="9524">
-              <a:solidFill>
-                <a:srgbClr val="434343"/>
-              </a:solidFill>
-            </a:ln>
-          </p:spPr>
-          <p:txBody>
-            <a:bodyPr wrap="square" lIns="0" tIns="0" rIns="0" bIns="0" rtlCol="0"/>
-            <a:lstStyle/>
-            <a:p>
-              <a:pPr defTabSz="1219170"/>
-              <a:endParaRPr sz="2400" kern="0">
-                <a:solidFill>
-                  <a:sysClr val="windowText" lastClr="000000"/>
-                </a:solidFill>
-              </a:endParaRPr>
-            </a:p>
-          </p:txBody>
-        </p:sp>
-      </p:grpSp>
-      <p:sp>
-        <p:nvSpPr>
-          <p:cNvPr id="10" name="object 10"/>
-          <p:cNvSpPr txBox="1"/>
-          <p:nvPr/>
-        </p:nvSpPr>
-        <p:spPr>
-          <a:xfrm>
-            <a:off x="8018145" y="3779841"/>
-            <a:ext cx="2049780" cy="386430"/>
-          </a:xfrm>
-          <a:prstGeom prst="rect">
-            <a:avLst/>
-          </a:prstGeom>
-        </p:spPr>
-        <p:txBody>
-          <a:bodyPr vert="horz" wrap="square" lIns="0" tIns="16933" rIns="0" bIns="0" rtlCol="0">
-            <a:spAutoFit/>
-          </a:bodyPr>
-          <a:lstStyle/>
-          <a:p>
-            <a:pPr marL="16933" defTabSz="1219170">
-              <a:spcBef>
-                <a:spcPts val="133"/>
-              </a:spcBef>
-            </a:pPr>
-            <a:r>
-              <a:rPr sz="2400" b="1" kern="0" dirty="0">
-                <a:solidFill>
-                  <a:srgbClr val="212D73"/>
-                </a:solidFill>
-                <a:latin typeface="Roboto"/>
-                <a:cs typeface="Roboto"/>
-              </a:rPr>
-              <a:t>Key</a:t>
-            </a:r>
-            <a:r>
-              <a:rPr sz="2400" b="1" kern="0" spc="-67" dirty="0">
-                <a:solidFill>
-                  <a:srgbClr val="212D73"/>
-                </a:solidFill>
-                <a:latin typeface="Roboto"/>
-                <a:cs typeface="Roboto"/>
-              </a:rPr>
-              <a:t> </a:t>
-            </a:r>
-            <a:r>
-              <a:rPr sz="2400" b="1" kern="0" dirty="0">
-                <a:solidFill>
-                  <a:srgbClr val="212D73"/>
-                </a:solidFill>
-                <a:latin typeface="Roboto"/>
-                <a:cs typeface="Roboto"/>
-              </a:rPr>
-              <a:t>Fob</a:t>
-            </a:r>
-            <a:r>
-              <a:rPr sz="2400" b="1" kern="0" spc="-60" dirty="0">
-                <a:solidFill>
-                  <a:srgbClr val="212D73"/>
-                </a:solidFill>
-                <a:latin typeface="Roboto"/>
-                <a:cs typeface="Roboto"/>
-              </a:rPr>
-              <a:t> </a:t>
-            </a:r>
-            <a:r>
-              <a:rPr sz="2400" b="1" kern="0" spc="-13" dirty="0">
-                <a:solidFill>
-                  <a:srgbClr val="212D73"/>
-                </a:solidFill>
-                <a:latin typeface="Roboto"/>
-                <a:cs typeface="Roboto"/>
-              </a:rPr>
-              <a:t>FCCID</a:t>
-            </a:r>
-            <a:endParaRPr sz="2400" kern="0">
-              <a:solidFill>
-                <a:sysClr val="windowText" lastClr="000000"/>
-              </a:solidFill>
-              <a:latin typeface="Roboto"/>
-              <a:cs typeface="Roboto"/>
-            </a:endParaRPr>
-          </a:p>
-        </p:txBody>
-      </p:sp>
-      <p:grpSp>
-        <p:nvGrpSpPr>
-          <p:cNvPr id="11" name="object 11"/>
-          <p:cNvGrpSpPr/>
-          <p:nvPr/>
-        </p:nvGrpSpPr>
-        <p:grpSpPr>
-          <a:xfrm>
-            <a:off x="4689667" y="4281966"/>
-            <a:ext cx="2786380" cy="1943100"/>
-            <a:chOff x="3517250" y="3211474"/>
-            <a:chExt cx="2089785" cy="1457325"/>
-          </a:xfrm>
-        </p:grpSpPr>
-        <p:pic>
-          <p:nvPicPr>
-            <p:cNvPr id="12" name="object 12"/>
-            <p:cNvPicPr/>
-            <p:nvPr/>
-          </p:nvPicPr>
-          <p:blipFill>
-            <a:blip r:embed="rId5" cstate="email">
-              <a:extLst>
-                <a:ext uri="{28A0092B-C50C-407E-A947-70E740481C1C}">
-                  <a14:useLocalDpi xmlns:a14="http://schemas.microsoft.com/office/drawing/2010/main"/>
-                </a:ext>
-              </a:extLst>
-            </a:blip>
-            <a:stretch>
-              <a:fillRect/>
-            </a:stretch>
-          </p:blipFill>
-          <p:spPr>
-            <a:xfrm>
-              <a:off x="3526775" y="3220999"/>
-              <a:ext cx="2070324" cy="1437749"/>
-            </a:xfrm>
-            <a:prstGeom prst="rect">
-              <a:avLst/>
-            </a:prstGeom>
-          </p:spPr>
-        </p:pic>
-        <p:sp>
-          <p:nvSpPr>
-            <p:cNvPr id="13" name="object 13"/>
-            <p:cNvSpPr/>
-            <p:nvPr/>
-          </p:nvSpPr>
-          <p:spPr>
-            <a:xfrm>
-              <a:off x="3522012" y="3216237"/>
-              <a:ext cx="2080260" cy="1447800"/>
-            </a:xfrm>
-            <a:custGeom>
-              <a:avLst/>
-              <a:gdLst/>
-              <a:ahLst/>
-              <a:cxnLst/>
-              <a:rect l="l" t="t" r="r" b="b"/>
-              <a:pathLst>
-                <a:path w="2080260" h="1447800">
-                  <a:moveTo>
-                    <a:pt x="0" y="0"/>
-                  </a:moveTo>
-                  <a:lnTo>
-                    <a:pt x="2079849" y="0"/>
-                  </a:lnTo>
-                  <a:lnTo>
-                    <a:pt x="2079849" y="1447274"/>
-                  </a:lnTo>
-                  <a:lnTo>
-                    <a:pt x="0" y="1447274"/>
-                  </a:lnTo>
-                  <a:lnTo>
-                    <a:pt x="0" y="0"/>
-                  </a:lnTo>
-                  <a:close/>
-                </a:path>
-              </a:pathLst>
-            </a:custGeom>
-            <a:ln w="9524">
-              <a:solidFill>
-                <a:srgbClr val="434343"/>
-              </a:solidFill>
-            </a:ln>
-          </p:spPr>
-          <p:txBody>
-            <a:bodyPr wrap="square" lIns="0" tIns="0" rIns="0" bIns="0" rtlCol="0"/>
-            <a:lstStyle/>
-            <a:p>
-              <a:pPr defTabSz="1219170"/>
-              <a:endParaRPr sz="2400" kern="0">
-                <a:solidFill>
-                  <a:sysClr val="windowText" lastClr="000000"/>
-                </a:solidFill>
-              </a:endParaRPr>
-            </a:p>
-          </p:txBody>
-        </p:sp>
-      </p:grpSp>
-      <p:sp>
-        <p:nvSpPr>
-          <p:cNvPr id="14" name="object 14"/>
-          <p:cNvSpPr txBox="1"/>
-          <p:nvPr/>
-        </p:nvSpPr>
-        <p:spPr>
-          <a:xfrm>
-            <a:off x="4603347" y="6318869"/>
-            <a:ext cx="2954867" cy="359073"/>
-          </a:xfrm>
-          <a:prstGeom prst="rect">
-            <a:avLst/>
-          </a:prstGeom>
-        </p:spPr>
-        <p:txBody>
-          <a:bodyPr vert="horz" wrap="square" lIns="0" tIns="0" rIns="0" bIns="0" rtlCol="0">
-            <a:spAutoFit/>
-          </a:bodyPr>
-          <a:lstStyle/>
-          <a:p>
-            <a:pPr marL="16933" defTabSz="1219170">
-              <a:lnSpc>
-                <a:spcPts val="2840"/>
-              </a:lnSpc>
-            </a:pPr>
-            <a:r>
-              <a:rPr sz="2400" b="1" kern="0" dirty="0">
-                <a:solidFill>
-                  <a:srgbClr val="212D73"/>
-                </a:solidFill>
-                <a:latin typeface="Roboto"/>
-                <a:cs typeface="Roboto"/>
-              </a:rPr>
-              <a:t>PS5</a:t>
-            </a:r>
-            <a:r>
-              <a:rPr sz="2400" b="1" kern="0" spc="-53" dirty="0">
-                <a:solidFill>
-                  <a:srgbClr val="212D73"/>
-                </a:solidFill>
-                <a:latin typeface="Roboto"/>
-                <a:cs typeface="Roboto"/>
-              </a:rPr>
-              <a:t> </a:t>
-            </a:r>
-            <a:r>
-              <a:rPr sz="2400" b="1" kern="0" spc="-13" dirty="0">
-                <a:solidFill>
-                  <a:srgbClr val="212D73"/>
-                </a:solidFill>
-                <a:latin typeface="Roboto"/>
-                <a:cs typeface="Roboto"/>
-              </a:rPr>
-              <a:t>Controller</a:t>
-            </a:r>
-            <a:r>
-              <a:rPr sz="2400" b="1" kern="0" spc="-47" dirty="0">
-                <a:solidFill>
-                  <a:srgbClr val="212D73"/>
-                </a:solidFill>
-                <a:latin typeface="Roboto"/>
-                <a:cs typeface="Roboto"/>
-              </a:rPr>
-              <a:t> </a:t>
-            </a:r>
-            <a:r>
-              <a:rPr sz="2400" b="1" kern="0" spc="-13" dirty="0">
-                <a:solidFill>
-                  <a:srgbClr val="212D73"/>
-                </a:solidFill>
-                <a:latin typeface="Roboto"/>
-                <a:cs typeface="Roboto"/>
-              </a:rPr>
-              <a:t>FCCID</a:t>
-            </a:r>
-            <a:endParaRPr sz="2400" kern="0">
-              <a:solidFill>
-                <a:sysClr val="windowText" lastClr="000000"/>
-              </a:solidFill>
-              <a:latin typeface="Roboto"/>
-              <a:cs typeface="Roboto"/>
-            </a:endParaRPr>
-          </a:p>
-        </p:txBody>
-      </p:sp>
-      <p:sp>
-        <p:nvSpPr>
-          <p:cNvPr id="15" name="object 15"/>
-          <p:cNvSpPr txBox="1"/>
-          <p:nvPr/>
-        </p:nvSpPr>
-        <p:spPr>
-          <a:xfrm>
-            <a:off x="11377941" y="6320327"/>
-            <a:ext cx="298027" cy="282129"/>
-          </a:xfrm>
-          <a:prstGeom prst="rect">
-            <a:avLst/>
-          </a:prstGeom>
-        </p:spPr>
-        <p:txBody>
-          <a:bodyPr vert="horz" wrap="square" lIns="0" tIns="0" rIns="0" bIns="0" rtlCol="0">
-            <a:spAutoFit/>
-          </a:bodyPr>
-          <a:lstStyle/>
-          <a:p>
-            <a:pPr marL="16933" defTabSz="1219170">
-              <a:lnSpc>
-                <a:spcPts val="2193"/>
-              </a:lnSpc>
-            </a:pPr>
-            <a:r>
-              <a:rPr sz="1867" kern="0" spc="-33" dirty="0">
-                <a:solidFill>
-                  <a:srgbClr val="434343"/>
-                </a:solidFill>
-                <a:latin typeface="Arial"/>
-                <a:cs typeface="Arial"/>
-              </a:rPr>
-              <a:t>38</a:t>
-            </a:r>
-            <a:endParaRPr sz="1867" kern="0">
-              <a:solidFill>
-                <a:sysClr val="windowText" lastClr="000000"/>
-              </a:solidFill>
-              <a:latin typeface="Arial"/>
-              <a:cs typeface="Arial"/>
-            </a:endParaRPr>
-          </a:p>
-        </p:txBody>
-      </p:sp>
-    </p:spTree>
-    <p:custDataLst>
-      <p:tags r:id="rId1"/>
-    </p:custDataLst>
-  </p:cSld>
-  <p:clrMapOvr>
-    <a:masterClrMapping/>
-  </p:clrMapOvr>
-</p:sld>
-</file>
-
-<file path=ppt/slides/slide8.xml><?xml version="1.0" encoding="utf-8"?>
-<p:sld xmlns:a="http://schemas.openxmlformats.org/drawingml/2006/main" xmlns:r="http://schemas.openxmlformats.org/officeDocument/2006/relationships" xmlns:p="http://schemas.openxmlformats.org/presentationml/2006/main">
-  <p:cSld>
-    <p:spTree>
-      <p:nvGrpSpPr>
-        <p:cNvPr id="1" name=""/>
-        <p:cNvGrpSpPr/>
-        <p:nvPr/>
-      </p:nvGrpSpPr>
-      <p:grpSpPr>
-        <a:xfrm>
-          <a:off x="0" y="0"/>
-          <a:ext cx="0" cy="0"/>
-          <a:chOff x="0" y="0"/>
-          <a:chExt cx="0" cy="0"/>
-        </a:xfrm>
-      </p:grpSpPr>
-      <p:sp>
-        <p:nvSpPr>
-          <p:cNvPr id="2" name="Text Placeholder 1">
-            <a:extLst>
-              <a:ext uri="{FF2B5EF4-FFF2-40B4-BE49-F238E27FC236}">
-                <a16:creationId xmlns:a16="http://schemas.microsoft.com/office/drawing/2014/main" id="{865F03D4-C60F-BCC2-00B2-3FC5A2869F43}"/>
-              </a:ext>
-            </a:extLst>
-          </p:cNvPr>
-          <p:cNvSpPr>
-            <a:spLocks noGrp="1"/>
-          </p:cNvSpPr>
-          <p:nvPr>
-            <p:ph type="body" sz="quarter" idx="10"/>
-          </p:nvPr>
-        </p:nvSpPr>
-        <p:spPr/>
-        <p:txBody>
-          <a:bodyPr/>
-          <a:lstStyle/>
-          <a:p>
-            <a:r>
-              <a:rPr lang="en-US" dirty="0"/>
-              <a:t>MAC ID Lookup</a:t>
-            </a:r>
-          </a:p>
-        </p:txBody>
-      </p:sp>
-      <p:sp>
-        <p:nvSpPr>
-          <p:cNvPr id="4" name="Text Placeholder 3">
-            <a:extLst>
-              <a:ext uri="{FF2B5EF4-FFF2-40B4-BE49-F238E27FC236}">
-                <a16:creationId xmlns:a16="http://schemas.microsoft.com/office/drawing/2014/main" id="{6CBFDCB8-2683-8890-D373-3B0A01A29E9D}"/>
-              </a:ext>
-            </a:extLst>
-          </p:cNvPr>
-          <p:cNvSpPr>
-            <a:spLocks noGrp="1"/>
-          </p:cNvSpPr>
-          <p:nvPr>
-            <p:ph type="body" sz="quarter" idx="12"/>
-          </p:nvPr>
-        </p:nvSpPr>
-        <p:spPr>
-          <a:xfrm>
-            <a:off x="270415" y="771556"/>
-            <a:ext cx="11658059" cy="5273644"/>
-          </a:xfrm>
-        </p:spPr>
-        <p:txBody>
-          <a:bodyPr/>
-          <a:lstStyle/>
-          <a:p>
-            <a:pPr marL="285750" indent="-285750">
-              <a:buFont typeface="Arial" panose="020B0604020202020204" pitchFamily="34" charset="0"/>
-              <a:buChar char="•"/>
-            </a:pPr>
-            <a:r>
-              <a:rPr lang="en-US" dirty="0">
-                <a:hlinkClick r:id="rId2"/>
-              </a:rPr>
-              <a:t>https://en.wikipedia.org/wiki/MAC_address</a:t>
-            </a:r>
-            <a:endParaRPr lang="en-US" dirty="0"/>
-          </a:p>
-          <a:p>
-            <a:pPr marL="285750" indent="-285750">
-              <a:buFont typeface="Arial" panose="020B0604020202020204" pitchFamily="34" charset="0"/>
-              <a:buChar char="•"/>
-            </a:pPr>
-            <a:r>
-              <a:rPr lang="en-US" dirty="0"/>
-              <a:t>Looking up the Medium Access Control (MAC) address</a:t>
-            </a:r>
-          </a:p>
-          <a:p>
-            <a:pPr marL="285750" indent="-285750">
-              <a:buFont typeface="Arial" panose="020B0604020202020204" pitchFamily="34" charset="0"/>
-              <a:buChar char="•"/>
-            </a:pPr>
-            <a:r>
-              <a:rPr lang="en-US" dirty="0"/>
-              <a:t>Important identification of device on local networks, wired or wireless</a:t>
-            </a:r>
-          </a:p>
-          <a:p>
-            <a:pPr marL="285750" indent="-285750">
-              <a:buFont typeface="Arial" panose="020B0604020202020204" pitchFamily="34" charset="0"/>
-              <a:buChar char="•"/>
-            </a:pPr>
-            <a:r>
-              <a:rPr lang="en-US" dirty="0"/>
-              <a:t>Works with Ethernet, </a:t>
-            </a:r>
-            <a:r>
-              <a:rPr lang="en-US" dirty="0" err="1"/>
-              <a:t>WiFi</a:t>
-            </a:r>
-            <a:r>
-              <a:rPr lang="en-US" dirty="0"/>
-              <a:t> and Bluetooth devices</a:t>
-            </a:r>
-          </a:p>
-          <a:p>
-            <a:pPr marL="285750" indent="-285750">
-              <a:buFont typeface="Arial" panose="020B0604020202020204" pitchFamily="34" charset="0"/>
-              <a:buChar char="•"/>
-            </a:pPr>
-            <a:r>
-              <a:rPr lang="en-US" dirty="0"/>
-              <a:t>Gives Manufacturer Organizationally Unique Identifier (OUI)</a:t>
-            </a:r>
-          </a:p>
-          <a:p>
-            <a:pPr marL="285750" indent="-285750">
-              <a:buFont typeface="Arial" panose="020B0604020202020204" pitchFamily="34" charset="0"/>
-              <a:buChar char="•"/>
-            </a:pPr>
-            <a:r>
-              <a:rPr lang="en-US" dirty="0">
-                <a:hlinkClick r:id="rId3"/>
-              </a:rPr>
-              <a:t>https://maclookup.app/</a:t>
-            </a:r>
-            <a:r>
-              <a:rPr lang="en-US" dirty="0"/>
-              <a:t> </a:t>
-            </a:r>
-          </a:p>
-          <a:p>
-            <a:pPr marL="285750" indent="-285750">
-              <a:buFont typeface="Arial" panose="020B0604020202020204" pitchFamily="34" charset="0"/>
-              <a:buChar char="•"/>
-            </a:pPr>
-            <a:endParaRPr lang="en-US" dirty="0"/>
-          </a:p>
-        </p:txBody>
-      </p:sp>
-      <p:pic>
-        <p:nvPicPr>
-          <p:cNvPr id="6" name="Picture 5">
-            <a:extLst>
-              <a:ext uri="{FF2B5EF4-FFF2-40B4-BE49-F238E27FC236}">
-                <a16:creationId xmlns:a16="http://schemas.microsoft.com/office/drawing/2014/main" id="{17233AFC-FA66-F154-7C50-1D6B83AEC69F}"/>
-              </a:ext>
-            </a:extLst>
-          </p:cNvPr>
-          <p:cNvPicPr>
-            <a:picLocks noChangeAspect="1"/>
-          </p:cNvPicPr>
-          <p:nvPr/>
-        </p:nvPicPr>
-        <p:blipFill>
-          <a:blip r:embed="rId4"/>
-          <a:stretch>
-            <a:fillRect/>
-          </a:stretch>
-        </p:blipFill>
-        <p:spPr>
-          <a:xfrm>
-            <a:off x="3219199" y="3865691"/>
-            <a:ext cx="5753599" cy="2179509"/>
-          </a:xfrm>
-          <a:prstGeom prst="rect">
-            <a:avLst/>
-          </a:prstGeom>
-        </p:spPr>
-      </p:pic>
-    </p:spTree>
-    <p:extLst>
-      <p:ext uri="{BB962C8B-B14F-4D97-AF65-F5344CB8AC3E}">
-        <p14:creationId xmlns:p14="http://schemas.microsoft.com/office/powerpoint/2010/main" val="4027383213"/>
-      </p:ext>
-    </p:extLst>
-  </p:cSld>
-  <p:clrMapOvr>
-    <a:masterClrMapping/>
-  </p:clrMapOvr>
-</p:sld>
-</file>
-
-<file path=ppt/slides/slide9.xml><?xml version="1.0" encoding="utf-8"?>
-<p:sld xmlns:a="http://schemas.openxmlformats.org/drawingml/2006/main" xmlns:r="http://schemas.openxmlformats.org/officeDocument/2006/relationships" xmlns:p="http://schemas.openxmlformats.org/presentationml/2006/main">
-  <p:cSld>
-    <p:spTree>
-      <p:nvGrpSpPr>
-        <p:cNvPr id="1" name=""/>
-        <p:cNvGrpSpPr/>
-        <p:nvPr/>
-      </p:nvGrpSpPr>
-      <p:grpSpPr>
-        <a:xfrm>
-          <a:off x="0" y="0"/>
-          <a:ext cx="0" cy="0"/>
-          <a:chOff x="0" y="0"/>
-          <a:chExt cx="0" cy="0"/>
-        </a:xfrm>
-      </p:grpSpPr>
-      <p:sp>
-        <p:nvSpPr>
-          <p:cNvPr id="2" name="Text Placeholder 1">
-            <a:extLst>
-              <a:ext uri="{FF2B5EF4-FFF2-40B4-BE49-F238E27FC236}">
-                <a16:creationId xmlns:a16="http://schemas.microsoft.com/office/drawing/2014/main" id="{898296D6-69DD-EFB3-27C5-5BB0CA443216}"/>
-              </a:ext>
-            </a:extLst>
-          </p:cNvPr>
-          <p:cNvSpPr>
-            <a:spLocks noGrp="1"/>
-          </p:cNvSpPr>
-          <p:nvPr>
-            <p:ph type="body" sz="quarter" idx="10"/>
-          </p:nvPr>
-        </p:nvSpPr>
-        <p:spPr/>
-        <p:txBody>
-          <a:bodyPr/>
-          <a:lstStyle/>
-          <a:p>
-            <a:r>
-              <a:rPr lang="en-US" dirty="0"/>
-              <a:t>Appendix</a:t>
-            </a:r>
-          </a:p>
-        </p:txBody>
-      </p:sp>
-      <p:sp>
-        <p:nvSpPr>
-          <p:cNvPr id="4" name="Text Placeholder 3">
-            <a:extLst>
-              <a:ext uri="{FF2B5EF4-FFF2-40B4-BE49-F238E27FC236}">
-                <a16:creationId xmlns:a16="http://schemas.microsoft.com/office/drawing/2014/main" id="{FBD158A4-E09F-9C63-2A15-EC5A41F8B727}"/>
-              </a:ext>
-            </a:extLst>
-          </p:cNvPr>
-          <p:cNvSpPr>
-            <a:spLocks noGrp="1"/>
-          </p:cNvSpPr>
-          <p:nvPr>
-            <p:ph type="body" sz="quarter" idx="12"/>
-          </p:nvPr>
-        </p:nvSpPr>
-        <p:spPr>
-          <a:xfrm>
-            <a:off x="270415" y="694944"/>
-            <a:ext cx="11658059" cy="5350256"/>
-          </a:xfrm>
-        </p:spPr>
-        <p:txBody>
-          <a:bodyPr/>
-          <a:lstStyle/>
-          <a:p>
-            <a:pPr marL="285750" indent="-285750">
-              <a:buFont typeface="Arial" panose="020B0604020202020204" pitchFamily="34" charset="0"/>
-              <a:buChar char="•"/>
-            </a:pPr>
-            <a:r>
-              <a:rPr lang="en-US" dirty="0"/>
-              <a:t>Neal’s </a:t>
-            </a:r>
-            <a:r>
-              <a:rPr lang="en-US" dirty="0" err="1"/>
-              <a:t>Github</a:t>
-            </a:r>
-            <a:r>
-              <a:rPr lang="en-US" dirty="0"/>
-              <a:t> repository for the lab:  </a:t>
-            </a:r>
-            <a:r>
-              <a:rPr lang="en-US" u="sng" dirty="0">
-                <a:hlinkClick r:id="rId2"/>
-              </a:rPr>
-              <a:t>https://github.com/nprobert/AutoISAC-ACT-AdvWireless</a:t>
-            </a:r>
-            <a:endParaRPr lang="en-US" u="sng" dirty="0"/>
-          </a:p>
-          <a:p>
-            <a:pPr marL="285750" indent="-285750">
-              <a:buFont typeface="Arial" panose="020B0604020202020204" pitchFamily="34" charset="0"/>
-              <a:buChar char="•"/>
-            </a:pPr>
-            <a:endParaRPr lang="en-US" dirty="0"/>
-          </a:p>
-          <a:p>
-            <a:pPr marL="285750" indent="-285750">
-              <a:buFont typeface="Arial" panose="020B0604020202020204" pitchFamily="34" charset="0"/>
-              <a:buChar char="•"/>
-            </a:pPr>
-            <a:r>
-              <a:rPr lang="en-US" dirty="0"/>
-              <a:t>If you want serious Wireless Training take the SANS 617 Wireless Penetration Testing and Ethical Hacking class: </a:t>
-            </a:r>
-            <a:r>
-              <a:rPr lang="en-US" dirty="0">
-                <a:hlinkClick r:id="rId3"/>
-              </a:rPr>
-              <a:t>https://www.sans.org/cyber-security-courses/wireless-penetration-testing-ethical-hacking</a:t>
-            </a:r>
-            <a:r>
-              <a:rPr lang="en-US" dirty="0"/>
-              <a:t> as it was just recently updated.</a:t>
-            </a:r>
-          </a:p>
-          <a:p>
-            <a:pPr marL="285750" indent="-285750">
-              <a:buFont typeface="Arial" panose="020B0604020202020204" pitchFamily="34" charset="0"/>
-              <a:buChar char="•"/>
-            </a:pPr>
-            <a:endParaRPr lang="en-US" dirty="0"/>
-          </a:p>
-          <a:p>
-            <a:pPr marL="285750" indent="-285750">
-              <a:buFont typeface="Arial" panose="020B0604020202020204" pitchFamily="34" charset="0"/>
-              <a:buChar char="•"/>
-            </a:pPr>
-            <a:r>
-              <a:rPr lang="en-US" dirty="0"/>
-              <a:t>Well known RF tools:</a:t>
-            </a:r>
-          </a:p>
-          <a:p>
-            <a:pPr marL="971550" lvl="1" indent="-285750"/>
-            <a:r>
-              <a:rPr lang="en-US" sz="1600" dirty="0"/>
-              <a:t>Flipper Zero: </a:t>
-            </a:r>
-            <a:r>
-              <a:rPr lang="en-US" sz="1600" dirty="0">
-                <a:hlinkClick r:id="rId4"/>
-              </a:rPr>
-              <a:t>https://flipper.net/</a:t>
-            </a:r>
-            <a:r>
-              <a:rPr lang="en-US" sz="1600" dirty="0"/>
-              <a:t> for Low Frequency (LF) work under 1Ghz</a:t>
-            </a:r>
-          </a:p>
-          <a:p>
-            <a:pPr marL="971550" lvl="1" indent="-285750"/>
-            <a:r>
-              <a:rPr lang="en-US" sz="1600" dirty="0" err="1"/>
-              <a:t>FreeWILI</a:t>
-            </a:r>
-            <a:r>
-              <a:rPr lang="en-US" sz="1600" dirty="0"/>
-              <a:t>: </a:t>
-            </a:r>
-            <a:r>
-              <a:rPr lang="en-US" sz="1600" dirty="0">
-                <a:hlinkClick r:id="rId5"/>
-              </a:rPr>
-              <a:t>https://freewili.com/</a:t>
-            </a:r>
-            <a:r>
-              <a:rPr lang="en-US" sz="1600" dirty="0"/>
-              <a:t> useful for car hacking</a:t>
-            </a:r>
-          </a:p>
-          <a:p>
-            <a:pPr marL="971550" lvl="1" indent="-285750"/>
-            <a:r>
-              <a:rPr lang="en-US" sz="1600" dirty="0" err="1"/>
-              <a:t>HackRF</a:t>
-            </a:r>
-            <a:r>
-              <a:rPr lang="en-US" sz="1600" dirty="0"/>
-              <a:t>: </a:t>
-            </a:r>
-            <a:r>
-              <a:rPr lang="en-US" sz="1600" dirty="0">
-                <a:hlinkClick r:id="rId6"/>
-              </a:rPr>
-              <a:t>https://greatscottgadgets.com/hackrf/</a:t>
-            </a:r>
-            <a:r>
-              <a:rPr lang="en-US" sz="1600" dirty="0"/>
-              <a:t> is a popular SDR</a:t>
-            </a:r>
-          </a:p>
-          <a:p>
-            <a:pPr marL="971550" lvl="1" indent="-285750"/>
-            <a:r>
-              <a:rPr lang="en-US" sz="1600" dirty="0"/>
-              <a:t>RTL-SDR: </a:t>
-            </a:r>
-            <a:r>
-              <a:rPr lang="en-US" sz="1600" dirty="0">
-                <a:hlinkClick r:id="rId7"/>
-              </a:rPr>
-              <a:t>https://www.rtl-sdr.com/</a:t>
-            </a:r>
-            <a:r>
-              <a:rPr lang="en-US" sz="1600" dirty="0"/>
-              <a:t> for SDR information and news</a:t>
-            </a:r>
-          </a:p>
-          <a:p>
-            <a:pPr marL="971550" lvl="1" indent="-285750"/>
-            <a:endParaRPr lang="en-US" dirty="0"/>
-          </a:p>
-          <a:p>
-            <a:pPr marL="285750" indent="-285750">
-              <a:buFont typeface="Arial" panose="020B0604020202020204" pitchFamily="34" charset="0"/>
-              <a:buChar char="•"/>
-            </a:pPr>
-            <a:r>
-              <a:rPr lang="en-US" dirty="0"/>
-              <a:t>A great tool for using with Software Defined Radios (SDR) is GNU Radio: </a:t>
-            </a:r>
-            <a:r>
-              <a:rPr lang="en-US" dirty="0">
-                <a:hlinkClick r:id="rId8"/>
-              </a:rPr>
-              <a:t>https://www.gnuradio.org/</a:t>
-            </a:r>
-            <a:r>
-              <a:rPr lang="en-US" dirty="0"/>
-              <a:t> </a:t>
-            </a:r>
-          </a:p>
-          <a:p>
-            <a:pPr marL="971550" lvl="1" indent="-285750"/>
-            <a:r>
-              <a:rPr lang="en-US" sz="1600" dirty="0"/>
-              <a:t>Tutorial: </a:t>
-            </a:r>
-            <a:r>
-              <a:rPr lang="en-US" sz="1600" dirty="0">
-                <a:hlinkClick r:id="rId9"/>
-              </a:rPr>
-              <a:t>https://www.gnuradio.org/news/2022-02-03-new-tutorials/</a:t>
-            </a:r>
-            <a:r>
-              <a:rPr lang="en-US" sz="1600" dirty="0"/>
-              <a:t> </a:t>
-            </a:r>
-          </a:p>
-        </p:txBody>
-      </p:sp>
-    </p:spTree>
-    <p:extLst>
-      <p:ext uri="{BB962C8B-B14F-4D97-AF65-F5344CB8AC3E}">
-        <p14:creationId xmlns:p14="http://schemas.microsoft.com/office/powerpoint/2010/main" val="3618102209"/>
-      </p:ext>
-    </p:extLst>
-  </p:cSld>
-  <p:clrMapOvr>
-    <a:masterClrMapping/>
-  </p:clrMapOvr>
-</p:sld>
-</file>
-
 <file path=ppt/tags/tag1.xml><?xml version="1.0" encoding="utf-8"?>
 <p:tagLst xmlns:a="http://schemas.openxmlformats.org/drawingml/2006/main" xmlns:r="http://schemas.openxmlformats.org/officeDocument/2006/relationships" xmlns:p="http://schemas.openxmlformats.org/presentationml/2006/main">
   <p:tag name="ARTICULATE_PROJECT_OPEN" val="0"/>
   <p:tag name="ARTICULATE_SLIDE_COUNT" val="155"/>
-</p:tagLst>
-</file>
-
-<file path=ppt/tags/tag2.xml><?xml version="1.0" encoding="utf-8"?>
-<p:tagLst xmlns:a="http://schemas.openxmlformats.org/drawingml/2006/main" xmlns:r="http://schemas.openxmlformats.org/officeDocument/2006/relationships" xmlns:p="http://schemas.openxmlformats.org/presentationml/2006/main">
-  <p:tag name="ARTICULATE_SLIDE_THUMBNAIL_REFRESH" val="1"/>
-</p:tagLst>
-</file>
-
-<file path=ppt/tags/tag3.xml><?xml version="1.0" encoding="utf-8"?>
-<p:tagLst xmlns:a="http://schemas.openxmlformats.org/drawingml/2006/main" xmlns:r="http://schemas.openxmlformats.org/officeDocument/2006/relationships" xmlns:p="http://schemas.openxmlformats.org/presentationml/2006/main">
-  <p:tag name="ARTICULATE_SLIDE_THUMBNAIL_REFRESH" val="1"/>
-</p:tagLst>
-</file>
-
-<file path=ppt/tags/tag4.xml><?xml version="1.0" encoding="utf-8"?>
-<p:tagLst xmlns:a="http://schemas.openxmlformats.org/drawingml/2006/main" xmlns:r="http://schemas.openxmlformats.org/officeDocument/2006/relationships" xmlns:p="http://schemas.openxmlformats.org/presentationml/2006/main">
-  <p:tag name="ARTICULATE_SLIDE_THUMBNAIL_REFRESH" val="1"/>
 </p:tagLst>
 </file>
 
@@ -10846,22 +7350,6 @@
 </file>
 
 <file path=customXml/item1.xml><?xml version="1.0" encoding="utf-8"?>
-<p:properties xmlns:p="http://schemas.microsoft.com/office/2006/metadata/properties" xmlns:xsi="http://www.w3.org/2001/XMLSchema-instance" xmlns:pc="http://schemas.microsoft.com/office/infopath/2007/PartnerControls">
-  <documentManagement>
-    <_dlc_DocId xmlns="c7a77415-c4a3-4262-8430-671f3e8707b6">7J4PPY27XH2W-901365475-257158</_dlc_DocId>
-    <_dlc_DocIdUrl xmlns="c7a77415-c4a3-4262-8430-671f3e8707b6">
-      <Url>https://automotivei.sharepoint.com/sites/PMO/_layouts/15/DocIdRedir.aspx?ID=7J4PPY27XH2W-901365475-257158</Url>
-      <Description>7J4PPY27XH2W-901365475-257158</Description>
-    </_dlc_DocIdUrl>
-    <TaxCatchAll xmlns="c7a77415-c4a3-4262-8430-671f3e8707b6" xsi:nil="true"/>
-    <lcf76f155ced4ddcb4097134ff3c332f xmlns="69a7259e-7a2c-42d5-bc84-25eccf0dce8b">
-      <Terms xmlns="http://schemas.microsoft.com/office/infopath/2007/PartnerControls"/>
-    </lcf76f155ced4ddcb4097134ff3c332f>
-  </documentManagement>
-</p:properties>
-</file>
-
-<file path=customXml/item2.xml><?xml version="1.0" encoding="utf-8"?>
 <?mso-contentType ?>
 <spe:Receivers xmlns:spe="http://schemas.microsoft.com/sharepoint/events">
   <Receiver>
@@ -10911,16 +7399,23 @@
 </spe:Receivers>
 </file>
 
-<file path=customXml/item3.xml><?xml version="1.0" encoding="utf-8"?>
-<?mso-contentType ?>
-<FormTemplates xmlns="http://schemas.microsoft.com/sharepoint/v3/contenttype/forms">
-  <Display>DocumentLibraryForm</Display>
-  <Edit>DocumentLibraryForm</Edit>
-  <New>DocumentLibraryForm</New>
-</FormTemplates>
+<file path=customXml/item2.xml><?xml version="1.0" encoding="utf-8"?>
+<p:properties xmlns:p="http://schemas.microsoft.com/office/2006/metadata/properties" xmlns:xsi="http://www.w3.org/2001/XMLSchema-instance" xmlns:pc="http://schemas.microsoft.com/office/infopath/2007/PartnerControls">
+  <documentManagement>
+    <_dlc_DocId xmlns="c7a77415-c4a3-4262-8430-671f3e8707b6">7J4PPY27XH2W-901365475-257158</_dlc_DocId>
+    <_dlc_DocIdUrl xmlns="c7a77415-c4a3-4262-8430-671f3e8707b6">
+      <Url>https://automotivei.sharepoint.com/sites/PMO/_layouts/15/DocIdRedir.aspx?ID=7J4PPY27XH2W-901365475-257158</Url>
+      <Description>7J4PPY27XH2W-901365475-257158</Description>
+    </_dlc_DocIdUrl>
+    <TaxCatchAll xmlns="c7a77415-c4a3-4262-8430-671f3e8707b6" xsi:nil="true"/>
+    <lcf76f155ced4ddcb4097134ff3c332f xmlns="69a7259e-7a2c-42d5-bc84-25eccf0dce8b">
+      <Terms xmlns="http://schemas.microsoft.com/office/infopath/2007/PartnerControls"/>
+    </lcf76f155ced4ddcb4097134ff3c332f>
+  </documentManagement>
+</p:properties>
 </file>
 
-<file path=customXml/item4.xml><?xml version="1.0" encoding="utf-8"?>
+<file path=customXml/item3.xml><?xml version="1.0" encoding="utf-8"?>
 <ct:contentTypeSchema xmlns:ct="http://schemas.microsoft.com/office/2006/metadata/contentType" xmlns:ma="http://schemas.microsoft.com/office/2006/metadata/properties/metaAttributes" ct:_="" ma:_="" ma:contentTypeName="Document" ma:contentTypeID="0x01010067B86F8708159745A0B6896184DE9576" ma:contentTypeVersion="19" ma:contentTypeDescription="Create a new document." ma:contentTypeScope="" ma:versionID="493bf26d373952ea1ae3b9e24cd19b33">
   <xsd:schema xmlns:xsd="http://www.w3.org/2001/XMLSchema" xmlns:xs="http://www.w3.org/2001/XMLSchema" xmlns:p="http://schemas.microsoft.com/office/2006/metadata/properties" xmlns:ns2="c7a77415-c4a3-4262-8430-671f3e8707b6" xmlns:ns3="69a7259e-7a2c-42d5-bc84-25eccf0dce8b" targetNamespace="http://schemas.microsoft.com/office/2006/metadata/properties" ma:root="true" ma:fieldsID="69c00e31f84d56e19bb090b7ea67ab52" ns2:_="" ns3:_="">
     <xsd:import namespace="c7a77415-c4a3-4262-8430-671f3e8707b6"/>
@@ -11206,7 +7701,24 @@
 </ct:contentTypeSchema>
 </file>
 
+<file path=customXml/item4.xml><?xml version="1.0" encoding="utf-8"?>
+<?mso-contentType ?>
+<FormTemplates xmlns="http://schemas.microsoft.com/sharepoint/v3/contenttype/forms">
+  <Display>DocumentLibraryForm</Display>
+  <Edit>DocumentLibraryForm</Edit>
+  <New>DocumentLibraryForm</New>
+</FormTemplates>
+</file>
+
 <file path=customXml/itemProps1.xml><?xml version="1.0" encoding="utf-8"?>
+<ds:datastoreItem xmlns:ds="http://schemas.openxmlformats.org/officeDocument/2006/customXml" ds:itemID="{54C592EF-85C1-482B-896B-DED434B6FCCC}">
+  <ds:schemaRefs>
+    <ds:schemaRef ds:uri="http://schemas.microsoft.com/sharepoint/events"/>
+  </ds:schemaRefs>
+</ds:datastoreItem>
+</file>
+
+<file path=customXml/itemProps2.xml><?xml version="1.0" encoding="utf-8"?>
 <ds:datastoreItem xmlns:ds="http://schemas.openxmlformats.org/officeDocument/2006/customXml" ds:itemID="{E71A463F-9F4B-47AC-91AA-3962FD8F3CE5}">
   <ds:schemaRefs>
     <ds:schemaRef ds:uri="http://schemas.microsoft.com/office/2006/metadata/properties"/>
@@ -11217,23 +7729,7 @@
 </ds:datastoreItem>
 </file>
 
-<file path=customXml/itemProps2.xml><?xml version="1.0" encoding="utf-8"?>
-<ds:datastoreItem xmlns:ds="http://schemas.openxmlformats.org/officeDocument/2006/customXml" ds:itemID="{54C592EF-85C1-482B-896B-DED434B6FCCC}">
-  <ds:schemaRefs>
-    <ds:schemaRef ds:uri="http://schemas.microsoft.com/sharepoint/events"/>
-  </ds:schemaRefs>
-</ds:datastoreItem>
-</file>
-
 <file path=customXml/itemProps3.xml><?xml version="1.0" encoding="utf-8"?>
-<ds:datastoreItem xmlns:ds="http://schemas.openxmlformats.org/officeDocument/2006/customXml" ds:itemID="{84EE72F3-C956-4A5B-833F-E761B5D8ACD8}">
-  <ds:schemaRefs>
-    <ds:schemaRef ds:uri="http://schemas.microsoft.com/sharepoint/v3/contenttype/forms"/>
-  </ds:schemaRefs>
-</ds:datastoreItem>
-</file>
-
-<file path=customXml/itemProps4.xml><?xml version="1.0" encoding="utf-8"?>
 <ds:datastoreItem xmlns:ds="http://schemas.openxmlformats.org/officeDocument/2006/customXml" ds:itemID="{8FEF19B7-7529-453B-A7D5-A8465340F17A}">
   <ds:schemaRefs>
     <ds:schemaRef ds:uri="http://schemas.microsoft.com/office/2006/metadata/contentType"/>
@@ -11250,4 +7746,12 @@
     <ds:schemaRef ds:uri="http://schemas.microsoft.com/internal/obd"/>
   </ds:schemaRefs>
 </ds:datastoreItem>
+</file>
+
+<file path=customXml/itemProps4.xml><?xml version="1.0" encoding="utf-8"?>
+<ds:datastoreItem xmlns:ds="http://schemas.openxmlformats.org/officeDocument/2006/customXml" ds:itemID="{84EE72F3-C956-4A5B-833F-E761B5D8ACD8}">
+  <ds:schemaRefs>
+    <ds:schemaRef ds:uri="http://schemas.microsoft.com/sharepoint/v3/contenttype/forms"/>
+  </ds:schemaRefs>
+</ds:datastoreItem>
 </file>
</xml_diff>